<commit_message>
Auto bot updater Build Course
</commit_message>
<xml_diff>
--- a/Day 20/SAP Build Training Day 20.pptx
+++ b/Day 20/SAP Build Training Day 20.pptx
@@ -2620,6 +2620,90 @@
 </inkml:ink>
 </file>
 
+<file path=ppt/ink/ink87.xml><?xml version="1.0" encoding="utf-8"?>
+<inkml:ink xmlns:inkml="http://www.w3.org/2003/InkML">
+  <inkml:definitions>
+    <inkml:context xml:id="ctx0">
+      <inkml:inkSource xml:id="inkSrc0">
+        <inkml:traceFormat>
+          <inkml:channel name="X" type="integer" min="-2.14748E9" max="2.14748E9" units="cm"/>
+          <inkml:channel name="Y" type="integer" min="-2.14748E9" max="2.14748E9" units="cm"/>
+          <inkml:channel name="F" type="integer" max="32767" units="dev"/>
+        </inkml:traceFormat>
+        <inkml:channelProperties>
+          <inkml:channelProperty channel="X" name="resolution" value="1000" units="1/cm"/>
+          <inkml:channelProperty channel="Y" name="resolution" value="1000" units="1/cm"/>
+          <inkml:channelProperty channel="F" name="resolution" value="0" units="1/dev"/>
+        </inkml:channelProperties>
+      </inkml:inkSource>
+      <inkml:timestamp xml:id="ts0" timeString="2025-08-07T05:14:06.420"/>
+    </inkml:context>
+    <inkml:brush xml:id="br0">
+      <inkml:brushProperty name="width" value="0.05" units="cm"/>
+      <inkml:brushProperty name="height" value="0.05" units="cm"/>
+      <inkml:brushProperty name="color" value="#F6630D"/>
+    </inkml:brush>
+  </inkml:definitions>
+  <inkml:trace contextRef="#ctx0" brushRef="#br0">1 1 24575,'0'0'-8191</inkml:trace>
+</inkml:ink>
+</file>
+
+<file path=ppt/ink/ink88.xml><?xml version="1.0" encoding="utf-8"?>
+<inkml:ink xmlns:inkml="http://www.w3.org/2003/InkML">
+  <inkml:definitions>
+    <inkml:context xml:id="ctx0">
+      <inkml:inkSource xml:id="inkSrc0">
+        <inkml:traceFormat>
+          <inkml:channel name="X" type="integer" min="-2.14748E9" max="2.14748E9" units="cm"/>
+          <inkml:channel name="Y" type="integer" min="-2.14748E9" max="2.14748E9" units="cm"/>
+          <inkml:channel name="F" type="integer" max="32767" units="dev"/>
+        </inkml:traceFormat>
+        <inkml:channelProperties>
+          <inkml:channelProperty channel="X" name="resolution" value="1000" units="1/cm"/>
+          <inkml:channelProperty channel="Y" name="resolution" value="1000" units="1/cm"/>
+          <inkml:channelProperty channel="F" name="resolution" value="0" units="1/dev"/>
+        </inkml:channelProperties>
+      </inkml:inkSource>
+      <inkml:timestamp xml:id="ts0" timeString="2025-08-07T05:14:09.691"/>
+    </inkml:context>
+    <inkml:brush xml:id="br0">
+      <inkml:brushProperty name="width" value="0.05" units="cm"/>
+      <inkml:brushProperty name="height" value="0.05" units="cm"/>
+      <inkml:brushProperty name="color" value="#F6630D"/>
+    </inkml:brush>
+  </inkml:definitions>
+  <inkml:trace contextRef="#ctx0" brushRef="#br0">1 92 24575,'-1'-1'0,"1"-1"0,0 1 0,0-1 0,0 1 0,1-1 0,-1 1 0,0-1 0,1 1 0,-1 0 0,1-1 0,-1 1 0,1-1 0,-1 1 0,1 0 0,0-1 0,0 1 0,0 0 0,0 0 0,0 0 0,0 0 0,0 0 0,0 0 0,2-2 0,-2 3 0,0 0 0,0 0 0,0 0 0,0 0 0,0 0 0,0 0 0,1 0 0,-1 0 0,0 0 0,0 1 0,0-1 0,0 0 0,0 1 0,0-1 0,0 0 0,0 1 0,0 0 0,0-1 0,-1 1 0,1-1 0,0 1 0,0 0 0,0 0 0,-1-1 0,1 1 0,0 0 0,-1 0 0,1 0 0,-1 0 0,1 0 0,-1 0 0,1 0 0,0 1 0,3 8 0,0 1 0,0-1 0,-1 1 0,-1-1 0,0 1 0,0 0 0,-1 0 0,0 0 0,-1 13 0,0-10 0,0 0 0,2 0 0,0 0 0,6 24 0,-8-36 0,0-1 0,1 0 0,-1 0 0,0 1 0,1-1 0,-1 0 0,1 0 0,-1 0 0,1 0 0,0 0 0,0 0 0,-1 0 0,1 0 0,0 0 0,0 0 0,0 0 0,0-1 0,0 1 0,0 0 0,0-1 0,0 1 0,0 0 0,0-1 0,0 1 0,2-1 0,-1 0 0,-1 0 0,1 0 0,0-1 0,-1 1 0,1-1 0,-1 1 0,1-1 0,-1 1 0,1-1 0,-1 0 0,1 0 0,-1 0 0,0 0 0,1 0 0,-1 0 0,1-2 0,7-7 0,0 0 0,-1-1 0,10-17 0,-16 24 0,48-92 0,-35 64 0,1 1 0,24-33 0,-40 63 0,1-1 0,0 1 0,-1 0 0,1 0 0,0 0 0,0 1 0,0-1 0,0 0 0,0 0 0,0 0 0,0 1 0,0-1 0,0 0 0,0 1 0,0-1 0,0 1 0,1-1 0,-1 1 0,0 0 0,0-1 0,2 1 0,-1 0 0,-1 1 0,0-1 0,0 0 0,0 1 0,0-1 0,0 1 0,1 0 0,-1-1 0,0 1 0,0 0 0,-1 0 0,1-1 0,0 1 0,0 0 0,0 0 0,0 0 0,0 2 0,4 6 0,0-1 0,-1 1 0,0 0 0,3 12 0,-6-17 0,9 35 0,-2 0 0,-2 0 0,2 49 0,-7-78 0,-1-8 0,0-1 0,0 1 0,0-1 0,0 0 0,1 1 0,-1-1 0,0 0 0,1 1 0,-1-1 0,1 0 0,-1 1 0,1-1 0,-1 0 0,1 0 0,0 0 0,0 1 0,0-1 0,0 0 0,0 0 0,2 1 0,-2-2 0,0 1 0,0-1 0,0 0 0,0 0 0,0-1 0,0 1 0,0 0 0,0 0 0,0 0 0,0-1 0,0 1 0,0 0 0,0-1 0,0 1 0,0-1 0,0 1 0,-1-1 0,1 1 0,0-1 0,0 0 0,0 0 0,-1 1 0,1-1 0,0 0 0,-1 0 0,1 0 0,-1 0 0,1 0 0,48-74 0,5-8 0,-49 76 0,1 0 0,0 0 0,0 1 0,1-1 0,0 2 0,0-1 0,1 1 0,10-6 0,-17 10 0,0 1 0,0-1 0,1 1 0,-1-1 0,0 1 0,1 0 0,-1-1 0,1 1 0,-1 0 0,0 0 0,1 0 0,-1 0 0,1 0 0,-1 0 0,1 0 0,-1 1 0,0-1 0,1 0 0,-1 1 0,0-1 0,1 1 0,-1-1 0,0 1 0,0 0 0,0 0 0,1-1 0,-1 1 0,0 0 0,0 0 0,0 0 0,0 0 0,0 0 0,-1 1 0,1-1 0,0 0 0,0 0 0,-1 0 0,2 3 0,2 6 0,0 0 0,-1 0 0,0 1 0,2 12 0,-1-5 0,-4-17 0,0 1 0,0-1 0,1 0 0,-1 1 0,1-1 0,-1 0 0,1 0 0,-1 0 0,1 0 0,0 1 0,0-1 0,-1 0 0,1 0 0,2 1 0,-3-2 0,1 1 0,-1-1 0,1 0 0,-1 0 0,1 0 0,-1 0 0,1 0 0,-1 0 0,1 0 0,-1 0 0,1 0 0,-1 0 0,1 0 0,-1 0 0,0 0 0,1 0 0,-1-1 0,1 1 0,-1 0 0,1 0 0,-1 0 0,0-1 0,1 1 0,-1 0 0,1-1 0,-1 1 0,1-1 0,3-4 0,1 0 0,-1-1 0,0 1 0,5-11 0,4-5 0,-13 20-80,1 1 0,0-1-1,-1 0 1,1 0 0,0 1-1,0-1 1,0 0 0,-1 1-1,1-1 1,0 1 0,0-1 0,0 1-1,0-1 1,0 1 0,0 0-1,1-1 1</inkml:trace>
+</inkml:ink>
+</file>
+
+<file path=ppt/ink/ink89.xml><?xml version="1.0" encoding="utf-8"?>
+<inkml:ink xmlns:inkml="http://www.w3.org/2003/InkML">
+  <inkml:definitions>
+    <inkml:context xml:id="ctx0">
+      <inkml:inkSource xml:id="inkSrc0">
+        <inkml:traceFormat>
+          <inkml:channel name="X" type="integer" min="-2.14748E9" max="2.14748E9" units="cm"/>
+          <inkml:channel name="Y" type="integer" min="-2.14748E9" max="2.14748E9" units="cm"/>
+          <inkml:channel name="F" type="integer" max="32767" units="dev"/>
+        </inkml:traceFormat>
+        <inkml:channelProperties>
+          <inkml:channelProperty channel="X" name="resolution" value="1000" units="1/cm"/>
+          <inkml:channelProperty channel="Y" name="resolution" value="1000" units="1/cm"/>
+          <inkml:channelProperty channel="F" name="resolution" value="0" units="1/dev"/>
+        </inkml:channelProperties>
+      </inkml:inkSource>
+      <inkml:timestamp xml:id="ts0" timeString="2025-08-07T05:14:10.334"/>
+    </inkml:context>
+    <inkml:brush xml:id="br0">
+      <inkml:brushProperty name="width" value="0.05" units="cm"/>
+      <inkml:brushProperty name="height" value="0.05" units="cm"/>
+      <inkml:brushProperty name="color" value="#F6630D"/>
+    </inkml:brush>
+  </inkml:definitions>
+  <inkml:trace contextRef="#ctx0" brushRef="#br0">17 28 24575,'-2'-2'0,"0"0"0,0 0 0,1 1 0,-1-1 0,1 0 0,0 0 0,0 0 0,0-1 0,0 1 0,-1-2 0,2 4 0,0 0 0,0-1 0,0 1 0,0 0 0,0 0 0,0 0 0,0 0 0,0 0 0,-1 0 0,1 0 0,0 0 0,0 0 0,0 0 0,0-1 0,1 1 0,-1 0 0,0 0 0,0 0 0,0 0 0,0 0 0,0 0 0,0 0 0,0 0 0,0 0 0,0 0 0,0-1 0,0 1 0,0 0 0,0 0 0,0 0 0,0 0 0,0 0 0,0 0 0,0 0 0,0 0 0,1 0 0,-1 0 0,0 0 0,0 0 0,0 0 0,0 0 0,0 0 0,0 0 0,0 0 0,0 0 0,0 0 0,0 0 0,0 0 0,1 0 0,-1 0 0,0 0 0,0 0 0,0 0 0,0 0 0,0 0 0,0 0 0,0 0 0,0 0 0,0 0 0,0 0 0,1 0 0,-1 0 0,0 0 0,0 0 0,0 0 0,0 0 0,13 12 0,0 4 0,-1 0 0,-1 0 0,0 1 0,8 18 0,29 75 0,-44-99 0,-4-10 0,0-1 0,0 1 0,1 0 0,-1 0 0,0-1 0,1 1 0,-1 0 0,1 0 0,-1-1 0,1 1 0,-1 0 0,1-1 0,-1 1 0,1-1 0,-1 1 0,1-1 0,0 1 0,-1-1 0,1 1 0,0-1 0,1 1 0,-1-1 0,-1 0 0,1 0 0,-1 0 0,1-1 0,0 1 0,-1 0 0,1 0 0,0-1 0,-1 1 0,1 0 0,-1-1 0,1 1 0,-1-1 0,1 1 0,-1 0 0,1-1 0,-1 1 0,1-1 0,-1 0 0,1 0 0,4-7 0,-1-1 0,0 1 0,4-12 0,-3 6 0,0 6 0,-1 0 0,1 1 0,0-1 0,0 1 0,10-10 0,-14 16 0,0 0 0,0 0 0,0 0 0,-1 0 0,1 0 0,0 0 0,0 1 0,0-1 0,0 0 0,0 1 0,0-1 0,0 1 0,1-1 0,-1 1 0,0-1 0,0 1 0,0 0 0,0 0 0,1-1 0,-1 1 0,0 0 0,0 0 0,1 0 0,-1 1 0,0-1 0,0 0 0,0 0 0,0 1 0,1-1 0,-1 0 0,0 1 0,0-1 0,0 1 0,0-1 0,0 1 0,0 0 0,0 0 0,0-1 0,0 1 0,0 0 0,0 0 0,-1 0 0,1 0 0,0 0 0,-1 0 0,1 0 0,0 0 0,-1 0 0,1 0 0,-1 0 0,1 2 0,3 7 0,-1 0 0,0 0 0,4 18 0,-6-20 0,0-1 0,1 1 0,0-1 0,0 0 0,1 0 0,0 0 0,0 0 0,7 11 0,-9-17 0,0 0 0,0 0 0,0 0 0,0 0 0,1 0 0,-1 0 0,0 0 0,0-1 0,1 1 0,-1 0 0,0-1 0,1 1 0,-1-1 0,0 1 0,1-1 0,-1 0 0,1 1 0,-1-1 0,1 0 0,-1 0 0,0 0 0,1 0 0,-1-1 0,1 1 0,-1 0 0,1 0 0,-1-1 0,0 1 0,1-1 0,-1 1 0,0-1 0,1 0 0,-1 0 0,0 1 0,0-1 0,0 0 0,2-2 0,6-4 0,-1 0 0,0-1 0,12-17 0,-14 18 0,16-21 0,-15 18 0,1-1 0,0 1 0,1 0 0,0 1 0,1 0 0,16-11 0,-25 19 0,1 0 0,-1 0 0,0 0 0,1 0 0,-1 1 0,1-1 0,-1 1 0,1-1 0,0 1 0,-1-1 0,1 1 0,0 0 0,-1 0 0,1 0 0,-1 0 0,1 0 0,0 0 0,-1 0 0,1 1 0,0-1 0,-1 1 0,2 0 0,-1 0 0,0 0 0,0 1 0,-1-1 0,1 1 0,0-1 0,-1 1 0,0 0 0,1 0 0,-1-1 0,0 1 0,0 0 0,0 0 0,0 0 0,1 3 0,1 6 0,-1 0 0,1 0 0,-2 1 0,1-1 0,-1 13 0,-1 2 191,3 46-1747,-1-57-5270</inkml:trace>
+</inkml:ink>
+</file>
+
 <file path=ppt/ink/ink9.xml><?xml version="1.0" encoding="utf-8"?>
 <inkml:ink xmlns:inkml="http://www.w3.org/2003/InkML">
   <inkml:definitions>
@@ -2644,6 +2728,202 @@
     </inkml:brush>
   </inkml:definitions>
   <inkml:trace contextRef="#ctx0" brushRef="#br0">70 411 24575,'-11'-19'0,"1"0"0,1-1 0,1 0 0,0-1 0,2 0 0,-5-26 0,9 37 0,0 0 0,1-1 0,0 1 0,1 0 0,0-1 0,1 1 0,0 0 0,0 0 0,1 0 0,0 0 0,1 0 0,0 0 0,1 0 0,0 1 0,6-11 0,-5 14 0,0 0 0,1 0 0,-1 1 0,1-1 0,0 1 0,0 1 0,1-1 0,-1 1 0,1 0 0,0 1 0,0-1 0,1 2 0,-1-1 0,0 1 0,1 0 0,0 0 0,-1 1 0,16-1 0,-7 1 0,1 1 0,-1 1 0,0 0 0,0 1 0,0 1 0,0 0 0,0 1 0,18 7 0,-20-4 0,1 0 0,-1 1 0,-1 0 0,1 1 0,-1 1 0,-1 0 0,0 0 0,0 2 0,-1-1 0,-1 1 0,0 1 0,0 0 0,-1 0 0,-1 1 0,0 0 0,-1 1 0,6 19 0,-8-22 0,-1 1 0,-1 0 0,0 0 0,-1 1 0,0-1 0,-1 0 0,-1 1 0,0-1 0,0 1 0,-2-1 0,0 0 0,0 1 0,-1-1 0,-1 0 0,0-1 0,0 1 0,-2-1 0,0 0 0,0 0 0,-1 0 0,-8 11 0,2-9 0,0 0 0,0 0 0,-2-1 0,1-1 0,-1-1 0,-1 0 0,0-1 0,-1 0 0,0-2 0,0 0 0,-1-1 0,0 0 0,0-2 0,0 0 0,-1-1 0,0-1 0,0 0 0,0-2 0,-27-1 0,39 0 57,0-1 0,-1 0 0,1 0 0,0-1 0,-9-3 0,14 4-135,0 0 0,0 0 1,0 0-1,0 0 1,0 0-1,0-1 1,1 1-1,-1 0 0,0-1 1,1 1-1,-1-1 1,1 0-1,0 0 1,-1 1-1,1-1 0,0 0 1,0 0-1,0 0 1,0 0-1,1 0 1,-2-3-1,1-13-6748</inkml:trace>
+</inkml:ink>
+</file>
+
+<file path=ppt/ink/ink90.xml><?xml version="1.0" encoding="utf-8"?>
+<inkml:ink xmlns:inkml="http://www.w3.org/2003/InkML">
+  <inkml:definitions>
+    <inkml:context xml:id="ctx0">
+      <inkml:inkSource xml:id="inkSrc0">
+        <inkml:traceFormat>
+          <inkml:channel name="X" type="integer" min="-2.14748E9" max="2.14748E9" units="cm"/>
+          <inkml:channel name="Y" type="integer" min="-2.14748E9" max="2.14748E9" units="cm"/>
+          <inkml:channel name="F" type="integer" max="32767" units="dev"/>
+        </inkml:traceFormat>
+        <inkml:channelProperties>
+          <inkml:channelProperty channel="X" name="resolution" value="1000" units="1/cm"/>
+          <inkml:channelProperty channel="Y" name="resolution" value="1000" units="1/cm"/>
+          <inkml:channelProperty channel="F" name="resolution" value="0" units="1/dev"/>
+        </inkml:channelProperties>
+      </inkml:inkSource>
+      <inkml:timestamp xml:id="ts0" timeString="2025-08-07T05:14:12.214"/>
+    </inkml:context>
+    <inkml:brush xml:id="br0">
+      <inkml:brushProperty name="width" value="0.05" units="cm"/>
+      <inkml:brushProperty name="height" value="0.05" units="cm"/>
+      <inkml:brushProperty name="color" value="#F6630D"/>
+    </inkml:brush>
+  </inkml:definitions>
+  <inkml:trace contextRef="#ctx0" brushRef="#br0">351 77 24575,'4'-20'0,"-3"17"0,-1 1 0,1-1 0,-1 0 0,1 1 0,-1-1 0,0 1 0,0-1 0,0-3 0,-1 5 0,1 0 0,-1 0 0,1 0 0,0 0 0,-1 0 0,0 0 0,1 1 0,-1-1 0,0 0 0,1 0 0,-1 0 0,0 1 0,0-1 0,0 0 0,0 1 0,1-1 0,-1 1 0,0-1 0,0 1 0,0-1 0,0 1 0,0 0 0,0-1 0,0 1 0,-2 0 0,-3-1 0,0 1 0,1-1 0,-1 1 0,0 1 0,1-1 0,-1 1 0,0 0 0,1 0 0,-1 1 0,1 0 0,-1 0 0,1 0 0,-10 6 0,-4 3 0,0 1 0,-19 16 0,17-11 0,1 1 0,1 0 0,-33 41 0,45-50 0,0 0 0,1 1 0,0 0 0,1 0 0,0 0 0,0 0 0,1 1 0,0 0 0,1 0 0,1 0 0,-3 21 0,5-26 0,0 0 0,1 1 0,-1-1 0,1 0 0,1 0 0,-1 0 0,1 0 0,0 0 0,0 0 0,1-1 0,0 1 0,0-1 0,0 1 0,4 4 0,-1-4 0,-1 1 0,2-1 0,-1 0 0,1-1 0,-1 1 0,1-1 0,1-1 0,-1 1 0,13 4 0,-11-5 0,0 0 0,1-1 0,-1 0 0,1-1 0,0 0 0,0 0 0,0-1 0,0-1 0,0 0 0,0 0 0,0 0 0,0-2 0,0 1 0,0-1 0,-1-1 0,1 1 0,0-2 0,9-4 0,-9 2 0,-1-1 0,1 0 0,-1-1 0,-1 0 0,1 0 0,-1-1 0,-1 0 0,0-1 0,0 1 0,-1-1 0,0-1 0,0 1 0,-2-1 0,1 0 0,4-18 0,-3 8 0,-1-1 0,-1 0 0,-1 0 0,-1 0 0,0-1 0,-2 1 0,-4-31 0,3 43 57,0 1 0,-1-1 0,-1 1 0,1-1 0,-7-13 0,7 20-147,1 0 0,-1 0 0,0 0 0,1 1 0,-2-1 1,1 0-1,0 1 0,0-1 0,-1 1 0,1 0 1,-1 0-1,0 0 0,0 0 0,0 0 0,0 1 0,0-1 1,0 1-1,-6-2 0,-18-1-6736</inkml:trace>
+</inkml:ink>
+</file>
+
+<file path=ppt/ink/ink91.xml><?xml version="1.0" encoding="utf-8"?>
+<inkml:ink xmlns:inkml="http://www.w3.org/2003/InkML">
+  <inkml:definitions>
+    <inkml:context xml:id="ctx0">
+      <inkml:inkSource xml:id="inkSrc0">
+        <inkml:traceFormat>
+          <inkml:channel name="X" type="integer" min="-2.14748E9" max="2.14748E9" units="cm"/>
+          <inkml:channel name="Y" type="integer" min="-2.14748E9" max="2.14748E9" units="cm"/>
+          <inkml:channel name="F" type="integer" max="32767" units="dev"/>
+        </inkml:traceFormat>
+        <inkml:channelProperties>
+          <inkml:channelProperty channel="X" name="resolution" value="1000" units="1/cm"/>
+          <inkml:channelProperty channel="Y" name="resolution" value="1000" units="1/cm"/>
+          <inkml:channelProperty channel="F" name="resolution" value="0" units="1/dev"/>
+        </inkml:channelProperties>
+      </inkml:inkSource>
+      <inkml:timestamp xml:id="ts0" timeString="2025-08-07T05:14:14.870"/>
+    </inkml:context>
+    <inkml:brush xml:id="br0">
+      <inkml:brushProperty name="width" value="0.05" units="cm"/>
+      <inkml:brushProperty name="height" value="0.05" units="cm"/>
+      <inkml:brushProperty name="color" value="#F6630D"/>
+    </inkml:brush>
+  </inkml:definitions>
+  <inkml:trace contextRef="#ctx0" brushRef="#br0">0 3325 24575,'1'4'0,"0"0"0,0-1 0,0 1 0,1 0 0,-1 0 0,1-1 0,3 7 0,3 4 0,34 73 0,5-2 0,84 117 0,-82-136 0,3-2 0,3-3 0,3-2 0,85 68 0,-49-55 0,3-5 0,147 78 0,44-1 0,5-12 0,332 100 0,113-16 0,-546-171 0,372 37 0,-470-76 0,118-9 0,-150-2 0,0-3 0,115-31 0,-34-5 0,174-80 0,-261 96 0,0-2 0,-2-3 0,-1-3 0,71-62 0,172-188 0,-285 274 0,69-75 0,-5-4 0,72-114 0,-104 142 0,52-83 0,-80 121 0,-2-2 0,-1 0 0,17-54 0,19-101 0,-7-2 0,18-205 0,-58 354 0,-1 0 0,-1 0 0,-2 0 0,-1 0 0,-10-35 0,-57-169 0,36 129 0,-107-384 0,69 109 0,61 288 0,-3 0 0,-5 1 0,-34-99 0,-5 50 0,41 101 0,7 12 0,1-1 0,2-1 0,1 1 0,-2-50 0,0 15 0,-4 1 0,-3 1 0,-28-74 0,42 136 0,-9-38 0,1-1 0,-5-60 0,11 74 0,4 29 0,0-1 0,0 1 0,0-1 0,0 0 0,0 1 0,0-1 0,0 1 0,0-1 0,0 0 0,-1 1 0,1-1 0,0 1 0,0-1 0,-1 1 0,1-1 0,0 1 0,-1-1 0,1 1 0,-1-1 0,1 1 0,0-1 0,-1 1 0,1 0 0,-1-1 0,1 1 0,-1 0 0,0-1 0,0 1 0,0 0 0,0 0 0,0 0 0,0 1 0,0-1 0,0 0 0,0 1 0,0-1 0,0 0 0,1 1 0,-1-1 0,0 1 0,0-1 0,0 1 0,-1 1 0,-30 34 0,27-29 0,-36 51 0,1 2 0,-40 86 0,61-110 0,-44 88 0,83-189 0,184-374 0,-204 438 0,4-5 0,-1 0 0,1 0 0,-1 1 0,10-10 0,-12 14 0,-1 1 0,1-1 0,-1 1 0,1-1 0,0 1 0,0-1 0,-1 1 0,1-1 0,0 1 0,0 0 0,-1-1 0,1 1 0,0 0 0,0 0 0,0 0 0,-1-1 0,1 1 0,0 0 0,0 0 0,0 0 0,0 0 0,0 0 0,-1 1 0,1-1 0,0 0 0,0 0 0,0 0 0,-1 1 0,1-1 0,0 1 0,0-1 0,-1 0 0,1 1 0,0-1 0,-1 1 0,1-1 0,0 1 0,-1 0 0,1-1 0,-1 1 0,1 0 0,-1-1 0,1 1 0,-1 0 0,1 0 0,-1-1 0,0 1 0,1 1 0,7 17 0,0 0 0,-1 0 0,-1 1 0,5 25 0,-1-6 0,46 171-1365,-37-141-5461</inkml:trace>
+</inkml:ink>
+</file>
+
+<file path=ppt/ink/ink92.xml><?xml version="1.0" encoding="utf-8"?>
+<inkml:ink xmlns:inkml="http://www.w3.org/2003/InkML">
+  <inkml:definitions>
+    <inkml:context xml:id="ctx0">
+      <inkml:inkSource xml:id="inkSrc0">
+        <inkml:traceFormat>
+          <inkml:channel name="X" type="integer" min="-2.14748E9" max="2.14748E9" units="cm"/>
+          <inkml:channel name="Y" type="integer" min="-2.14748E9" max="2.14748E9" units="cm"/>
+          <inkml:channel name="F" type="integer" max="32767" units="dev"/>
+        </inkml:traceFormat>
+        <inkml:channelProperties>
+          <inkml:channelProperty channel="X" name="resolution" value="1000" units="1/cm"/>
+          <inkml:channelProperty channel="Y" name="resolution" value="1000" units="1/cm"/>
+          <inkml:channelProperty channel="F" name="resolution" value="0" units="1/dev"/>
+        </inkml:channelProperties>
+      </inkml:inkSource>
+      <inkml:timestamp xml:id="ts0" timeString="2025-08-07T05:14:16.369"/>
+    </inkml:context>
+    <inkml:brush xml:id="br0">
+      <inkml:brushProperty name="width" value="0.05" units="cm"/>
+      <inkml:brushProperty name="height" value="0.05" units="cm"/>
+      <inkml:brushProperty name="color" value="#F6630D"/>
+    </inkml:brush>
+  </inkml:definitions>
+  <inkml:trace contextRef="#ctx0" brushRef="#br0">1 53 24575,'0'-4'0,"0"0"0,0 0 0,1 1 0,0-1 0,0 0 0,0 1 0,3-7 0,-4 9 0,0 0 0,1 1 0,-1-1 0,0 1 0,1-1 0,-1 1 0,0 0 0,1-1 0,-1 1 0,0-1 0,1 1 0,-1 0 0,1-1 0,-1 1 0,1 0 0,-1-1 0,1 1 0,-1 0 0,1 0 0,0 0 0,-1-1 0,2 1 0,-2 0 0,1 1 0,0-1 0,0 0 0,0 1 0,0-1 0,0 1 0,0-1 0,-1 1 0,1-1 0,0 1 0,0-1 0,-1 1 0,1 0 0,0-1 0,-1 1 0,1 0 0,-1 0 0,1-1 0,0 2 0,5 10 0,0 1 0,-1-1 0,0 1 0,-1 0 0,0 1 0,-1-1 0,2 20 0,5 22 0,-8-48 0,0 0 0,0 1 0,1-1 0,0 0 0,0 0 0,1-1 0,7 12 0,-10-17 0,0 1 0,0-1 0,1 0 0,-1 0 0,1 1 0,-1-1 0,1 0 0,-1 0 0,1 0 0,0-1 0,-1 1 0,1 0 0,0-1 0,0 1 0,0-1 0,-1 1 0,1-1 0,0 0 0,0 0 0,0 0 0,0 0 0,0 0 0,-1 0 0,1 0 0,0-1 0,0 1 0,0-1 0,0 1 0,-1-1 0,1 0 0,0 0 0,-1 1 0,1-1 0,-1 0 0,1-1 0,1 0 0,16-13 0,0-1 0,-2-1 0,0 0 0,26-34 0,-11 12 0,-12 15 0,-11 12 0,0 1 0,1 0 0,0 1 0,0 0 0,1 1 0,22-15 0,-33 24 0,1-1 0,0 1 0,0-1 0,0 1 0,0-1 0,0 1 0,0 0 0,0 0 0,0-1 0,0 1 0,0 0 0,0 0 0,0 0 0,0 0 0,0 0 0,0 0 0,0 1 0,0-1 0,-1 0 0,1 0 0,0 1 0,0-1 0,0 0 0,0 1 0,0-1 0,0 1 0,0-1 0,-1 1 0,1 0 0,0-1 0,0 1 0,-1 0 0,1-1 0,-1 1 0,1 0 0,0 0 0,-1 0 0,0 0 0,1-1 0,-1 1 0,1 0 0,-1 0 0,0 0 0,1 2 0,1 4 0,0 1 0,-1 0 0,0 1 0,1 9 0,-2-12 0,1 4 0,-1 1 0,1 0 0,0 0 0,1 0 0,0 0 0,1-1 0,0 1 0,6 11 0,-9-20 0,1-1 0,0 0 0,0 1 0,0-1 0,0 0 0,0 0 0,1 0 0,-1 0 0,0 0 0,0 0 0,1 0 0,-1 0 0,1 0 0,-1-1 0,1 1 0,-1-1 0,1 1 0,-1-1 0,1 1 0,-1-1 0,1 0 0,0 0 0,-1 0 0,1 0 0,-1 0 0,1 0 0,0 0 0,-1 0 0,1-1 0,-1 1 0,1-1 0,-1 1 0,1-1 0,-1 1 0,1-1 0,1-2 0,8-2 0,-1-2 0,0 0 0,17-15 0,-17 14 0,32-29 0,-29 25 0,0 0 0,1 0 0,1 2 0,0 0 0,24-13 0,-38 22 7,0 1-1,0-1 0,-1 1 1,1 0-1,0-1 0,0 1 0,-1 0 1,1 0-1,0-1 0,0 1 1,0 0-1,0 0 0,0 0 1,-1 0-1,1 0 0,0 0 1,0 0-1,0 0 0,0 1 1,-1-1-1,1 0 0,0 0 1,0 1-1,0-1 0,-1 0 1,2 2-1,-1-1 4,-1 0 0,1 0 0,-1 0 0,1 0 0,-1 0 0,0 0 0,0 0 0,1 0 0,-1 0 0,0 0 0,0 1 0,0-1 0,0 0 0,0 0 0,0 0 1,-1 2-1,-1 5-437,0 0 0,-1 0 1,-6 15-1,-6 5-6399</inkml:trace>
+</inkml:ink>
+</file>
+
+<file path=ppt/ink/ink93.xml><?xml version="1.0" encoding="utf-8"?>
+<inkml:ink xmlns:inkml="http://www.w3.org/2003/InkML">
+  <inkml:definitions>
+    <inkml:context xml:id="ctx0">
+      <inkml:inkSource xml:id="inkSrc0">
+        <inkml:traceFormat>
+          <inkml:channel name="X" type="integer" min="-2.14748E9" max="2.14748E9" units="cm"/>
+          <inkml:channel name="Y" type="integer" min="-2.14748E9" max="2.14748E9" units="cm"/>
+          <inkml:channel name="F" type="integer" max="32767" units="dev"/>
+        </inkml:traceFormat>
+        <inkml:channelProperties>
+          <inkml:channelProperty channel="X" name="resolution" value="1000" units="1/cm"/>
+          <inkml:channelProperty channel="Y" name="resolution" value="1000" units="1/cm"/>
+          <inkml:channelProperty channel="F" name="resolution" value="0" units="1/dev"/>
+        </inkml:channelProperties>
+      </inkml:inkSource>
+      <inkml:timestamp xml:id="ts0" timeString="2025-08-07T05:14:16.927"/>
+    </inkml:context>
+    <inkml:brush xml:id="br0">
+      <inkml:brushProperty name="width" value="0.05" units="cm"/>
+      <inkml:brushProperty name="height" value="0.05" units="cm"/>
+      <inkml:brushProperty name="color" value="#F6630D"/>
+    </inkml:brush>
+  </inkml:definitions>
+  <inkml:trace contextRef="#ctx0" brushRef="#br0">6 35 24575,'-6'-2'0,"11"-2"0,12-2 0,-11 6 0,0 1 0,0 0 0,0 0 0,0 0 0,0 1 0,0 0 0,0 0 0,0 0 0,0 1 0,-1-1 0,0 1 0,1 1 0,-1-1 0,0 1 0,-1 0 0,1 0 0,5 7 0,-1-1 0,-1 0 0,0 1 0,-1 0 0,0 1 0,0 0 0,8 24 0,-14-33 0,1 1 0,-1-1 0,0 0 0,1 0 0,-1 0 0,1 0 0,0 0 0,0-1 0,4 6 0,-5-8 0,-1 0 0,1 1 0,0-1 0,-1 0 0,1 1 0,0-1 0,-1 0 0,1 0 0,0 1 0,-1-1 0,1 0 0,0 0 0,-1 0 0,1 0 0,0 0 0,-1 0 0,1 0 0,0 0 0,-1 0 0,2-1 0,-1 1 0,1-1 0,0 0 0,0 0 0,-1 0 0,1 0 0,0 0 0,-1-1 0,1 1 0,-1 0 0,2-2 0,56-68 0,-42 48 0,1 2 0,1 0 0,34-29 0,-52 49 0,1 0 0,-1-1 0,1 1 0,-1 0 0,1 0 0,0 0 0,-1 0 0,1 1 0,0-1 0,0 0 0,0 1 0,0-1 0,0 1 0,0 0 0,0-1 0,0 1 0,3 0 0,-3 1 0,-1 0 0,0-1 0,1 1 0,-1 0 0,0 0 0,0 0 0,1 0 0,-1 0 0,0 0 0,0 0 0,0 0 0,0 1 0,-1-1 0,1 0 0,0 0 0,0 1 0,-1-1 0,1 1 0,-1-1 0,1 0 0,-1 1 0,0-1 0,1 4 0,6 52 0,-7-47 0,0 0 0,1-1 0,1 1 0,0 0 0,0-1 0,6 18 0,-6-25 0,-1 0 0,0 0 0,1 0 0,-1 0 0,1 0 0,0-1 0,-1 1 0,1 0 0,0-1 0,0 1 0,0-1 0,0 0 0,1 0 0,-1 1 0,0-1 0,0-1 0,1 1 0,-1 0 0,0-1 0,1 1 0,-1-1 0,1 1 0,-1-1 0,1 0 0,-1 0 0,0-1 0,1 1 0,-1 0 0,1-1 0,2 0 0,8-2 0,0-1 0,-1 0 0,1-1 0,12-7 0,37-23 0,-46 25 0,1 0 0,1 1 0,-1 1 0,1 1 0,22-7 0,-38 14-105,1-1 0,-1 1 0,1-1 0,-1 1 0,0 0 0,1 0 0,-1 0 0,1 0 0,-1 1 0,1-1 0,-1 1 0,3 0 0,4 4-6721</inkml:trace>
+</inkml:ink>
+</file>
+
+<file path=ppt/ink/ink94.xml><?xml version="1.0" encoding="utf-8"?>
+<inkml:ink xmlns:inkml="http://www.w3.org/2003/InkML">
+  <inkml:definitions>
+    <inkml:context xml:id="ctx0">
+      <inkml:inkSource xml:id="inkSrc0">
+        <inkml:traceFormat>
+          <inkml:channel name="X" type="integer" min="-2.14748E9" max="2.14748E9" units="cm"/>
+          <inkml:channel name="Y" type="integer" min="-2.14748E9" max="2.14748E9" units="cm"/>
+          <inkml:channel name="F" type="integer" max="32767" units="dev"/>
+        </inkml:traceFormat>
+        <inkml:channelProperties>
+          <inkml:channelProperty channel="X" name="resolution" value="1000" units="1/cm"/>
+          <inkml:channelProperty channel="Y" name="resolution" value="1000" units="1/cm"/>
+          <inkml:channelProperty channel="F" name="resolution" value="0" units="1/dev"/>
+        </inkml:channelProperties>
+      </inkml:inkSource>
+      <inkml:timestamp xml:id="ts0" timeString="2025-08-07T05:14:20.836"/>
+    </inkml:context>
+    <inkml:brush xml:id="br0">
+      <inkml:brushProperty name="width" value="0.05" units="cm"/>
+      <inkml:brushProperty name="height" value="0.05" units="cm"/>
+      <inkml:brushProperty name="color" value="#F6630D"/>
+    </inkml:brush>
+  </inkml:definitions>
+  <inkml:trace contextRef="#ctx0" brushRef="#br0">10 1241 24575,'-5'-19'0,"5"17"0,-1 1 0,0-1 0,1 1 0,-1-1 0,1 1 0,0-1 0,-1 0 0,1 1 0,0-1 0,0 0 0,0 1 0,0-1 0,0 0 0,0 1 0,1-1 0,0-1 0,5-13 0,2 0 0,0 1 0,1 0 0,0 1 0,21-24 0,10-18 0,-20 24 0,-3-2 0,-1 0 0,22-65 0,19-115 0,-22 73 0,-27 112 0,2 0 0,16-36 0,-19 52 0,0 1 0,0 0 0,1 1 0,0-1 0,1 2 0,0-1 0,15-12 0,44-43 0,-29 27 0,71-76 0,-108 113 0,0 0 0,0 0 0,0 0 0,1 0 0,-1 0 0,1 1 0,-1-1 0,1 1 0,-1-1 0,1 1 0,4-1 0,-5 2 0,0 0 0,0 1 0,0-1 0,0 0 0,0 1 0,0 0 0,0-1 0,0 1 0,0 0 0,0 0 0,-1 0 0,1 0 0,0 0 0,-1 1 0,1-1 0,0 0 0,1 3 0,8 6 0,0 0 0,-1 1 0,0 0 0,11 19 0,-16-22 0,-1-1 0,0 1 0,-1 0 0,0 0 0,0 1 0,-1-1 0,0 1 0,0-1 0,0 10 0,4 43 0,21 88 0,-23-122 0,0 0 0,-2 0 0,-2 46 0,0-37 0,4 45 0,13 128 0,-14-163 0,2 44 0,27 263 0,-9-154 0,-17-128 0,3 1 0,26 101 0,75 175 0,-78-262 0,86 161 0,-26-95 0,8-5 0,143 164 0,128 168 0,82 95 0,36-96 0,49-56 0,-281-243 0,402 210 0,-615-366 0,1-1 0,1-3 0,1-2 0,89 21 0,-122-35 0,-12-2 0,0-1 0,0 1 0,0-1 0,0 0 0,0 1 0,0-1 0,0 0 0,0 0 0,2 0 0,-1-6 0,-8-9 0,2 9 0,0 1 0,1 0 0,0 0 0,0-1 0,0 0 0,1 1 0,0-1 0,0 0 0,0 1 0,1-1 0,0 0 0,0 0 0,0 0 0,1 1 0,-1-1 0,2 0 0,-1 0 0,4-9 0,-3 9 0,0 1 0,-1 0 0,0-1 0,0 1 0,0-1 0,-1 0 0,0 1 0,0-1 0,0 1 0,-3-11 0,2 12 0,0 0 0,-1 1 0,0-1 0,0 1 0,0 0 0,0-1 0,0 1 0,-1 0 0,1 0 0,-1 0 0,0 1 0,0-1 0,0 1 0,0-1 0,-1 1 0,-3-2 0,-6-3 0,1 0 0,-16-5 0,25 11 0,0-1 0,0 1 0,0 0 0,0 1 0,0-1 0,0 0 0,0 1 0,0 0 0,0 0 0,-1 0 0,1 0 0,0 0 0,0 1 0,0-1 0,0 1 0,-4 1 0,6-1 0,0 0 0,-1 0 0,1 0 0,0 0 0,0 0 0,0 0 0,0 1 0,0-1 0,0 0 0,0 1 0,0-1 0,0 1 0,1-1 0,-1 1 0,1-1 0,-1 1 0,1-1 0,-1 1 0,1 0 0,0-1 0,0 1 0,0 0 0,0-1 0,0 1 0,0 0 0,0-1 0,0 1 0,1-1 0,0 3 0,1 4 0,0-1 0,1 0 0,0 0 0,7 13 0,14 17 0,1-2 0,46 50 0,-13-18 0,-55-64 0,-1 0 0,0 0 0,0 1 0,0-1 0,0 0 0,0 1 0,-1-1 0,3 8 0,-4-9 0,0-1 0,0 0 0,0 1 0,0-1 0,0 0 0,0 1 0,0-1 0,0 1 0,-1-1 0,1 0 0,0 1 0,-1-1 0,1 0 0,-1 0 0,1 1 0,-1-1 0,0 0 0,0 0 0,1 0 0,-1 0 0,0 0 0,0 0 0,0 0 0,0 0 0,0 0 0,-1 0 0,1 0 0,-2 0 0,-4 3 0,-1 0 0,0-1 0,0 0 0,0-1 0,-1 1 0,-13 1 0,-57 2 0,31-2 0,-11 2-455,1 3 0,-60 17 0,89-17-6371</inkml:trace>
+</inkml:ink>
+</file>
+
+<file path=ppt/ink/ink95.xml><?xml version="1.0" encoding="utf-8"?>
+<inkml:ink xmlns:inkml="http://www.w3.org/2003/InkML">
+  <inkml:definitions>
+    <inkml:context xml:id="ctx0">
+      <inkml:inkSource xml:id="inkSrc0">
+        <inkml:traceFormat>
+          <inkml:channel name="X" type="integer" min="-2.14748E9" max="2.14748E9" units="cm"/>
+          <inkml:channel name="Y" type="integer" min="-2.14748E9" max="2.14748E9" units="cm"/>
+          <inkml:channel name="F" type="integer" max="32767" units="dev"/>
+        </inkml:traceFormat>
+        <inkml:channelProperties>
+          <inkml:channelProperty channel="X" name="resolution" value="1000" units="1/cm"/>
+          <inkml:channelProperty channel="Y" name="resolution" value="1000" units="1/cm"/>
+          <inkml:channelProperty channel="F" name="resolution" value="0" units="1/dev"/>
+        </inkml:channelProperties>
+      </inkml:inkSource>
+      <inkml:timestamp xml:id="ts0" timeString="2025-08-07T05:14:21.537"/>
+    </inkml:context>
+    <inkml:brush xml:id="br0">
+      <inkml:brushProperty name="width" value="0.05" units="cm"/>
+      <inkml:brushProperty name="height" value="0.05" units="cm"/>
+      <inkml:brushProperty name="color" value="#F6630D"/>
+    </inkml:brush>
+  </inkml:definitions>
+  <inkml:trace contextRef="#ctx0" brushRef="#br0">1524 456 24575,'2'-1'0,"28"-19"0,54-47 0,-78 61 0,1-1 0,-1 1 0,-1-1 0,1 0 0,-1 0 0,0 0 0,-1-1 0,1 0 0,-2 0 0,1 0 0,-1 0 0,0-1 0,2-15 0,-4 19 0,-1 0 0,0 1 0,0-1 0,-1 0 0,1 0 0,-1 0 0,0 1 0,-1-1 0,1 0 0,-1 1 0,0-1 0,0 1 0,-3-6 0,0 3 0,0 0 0,-1 0 0,0 1 0,0 0 0,0 0 0,-14-10 0,0 3 0,0 2 0,-1 0 0,-1 1 0,-35-12 0,7 8-42,-1 1-1,0 3 0,0 2 0,-1 3 1,0 1-1,-1 3 0,-92 10 0,84-1-5,0 3-1,0 2 0,1 3 0,1 3 0,1 2 0,-71 37 1,91-38 48,0 3 0,2 0 0,1 3 0,1 1 0,1 1 0,1 2 0,2 1 0,1 1 0,1 2 0,-29 47 0,41-54 0,1 0 0,1 1 0,2 0 0,0 1 0,2 0 0,1 1 0,2 0 0,1 1 0,1-1 0,2 1 0,0 0 0,3 0 0,0 0 0,2 0 0,7 36 0,-2-37 21,0 1 1,3-1 0,0-1 0,2 0 0,1 0 0,1-2 0,2 1 0,30 40 0,-19-35-112,1-2 1,1-1-1,1-1 0,2-2 0,66 45 0,-43-39-109,1-2 0,1-3 0,81 28 0,-59-30 8,1-3-1,83 11 1,-69-20-235,0-5 0,1-4 1,179-12-1,-193-2 445,-2-3-1,1-4 1,-2-3 0,145-56 0,-175 54 9,86-52 0,-105 54-123,0-2 0,-2-1 0,50-49 1,-64 56 47,0 0 0,-2-1 1,1 0-1,-2 0 0,0-1 0,-1-1 1,-1 0-1,7-22 0,-11 25 42,0 0-1,-1 0 1,-1-1-1,-1 1 1,0-1-1,-1 1 1,0 0-1,-1-1 0,-1 1 1,-1-1-1,-6-22 1,0 13-11,-1 0 1,-1 0 0,-1 1-1,-1 0 1,-1 1 0,-1 0-1,-1 2 1,-1 0 0,-25-24-1,-6 0-377,-2 1 0,-95-62 0,9 23 112,-246-112-1,121 82-1199</inkml:trace>
+</inkml:ink>
+</file>
+
+<file path=ppt/ink/ink96.xml><?xml version="1.0" encoding="utf-8"?>
+<inkml:ink xmlns:inkml="http://www.w3.org/2003/InkML">
+  <inkml:definitions>
+    <inkml:context xml:id="ctx0">
+      <inkml:inkSource xml:id="inkSrc0">
+        <inkml:traceFormat>
+          <inkml:channel name="X" type="integer" min="-2.14748E9" max="2.14748E9" units="cm"/>
+          <inkml:channel name="Y" type="integer" min="-2.14748E9" max="2.14748E9" units="cm"/>
+          <inkml:channel name="F" type="integer" max="32767" units="dev"/>
+        </inkml:traceFormat>
+        <inkml:channelProperties>
+          <inkml:channelProperty channel="X" name="resolution" value="1000" units="1/cm"/>
+          <inkml:channelProperty channel="Y" name="resolution" value="1000" units="1/cm"/>
+          <inkml:channelProperty channel="F" name="resolution" value="0" units="1/dev"/>
+        </inkml:channelProperties>
+      </inkml:inkSource>
+      <inkml:timestamp xml:id="ts0" timeString="2025-08-07T05:14:30.775"/>
+    </inkml:context>
+    <inkml:brush xml:id="br0">
+      <inkml:brushProperty name="width" value="0.05" units="cm"/>
+      <inkml:brushProperty name="height" value="0.05" units="cm"/>
+      <inkml:brushProperty name="color" value="#F6630D"/>
+    </inkml:brush>
+  </inkml:definitions>
+  <inkml:trace contextRef="#ctx0" brushRef="#br0">1 0 24575,'5'3'0,"17"0"0,28 0 0,34-1 0,34 0 0,35-1 0,27 0 0,26-1-885,14 0 885,2 0 0,-18 0 0,-37-1 0,-42 1 0,-42 0-7306</inkml:trace>
 </inkml:ink>
 </file>
 
@@ -17163,8 +17443,8 @@
           </a:p>
         </p:txBody>
       </p:sp>
-      <mc:AlternateContent xmlns:mc="http://schemas.openxmlformats.org/markup-compatibility/2006">
-        <mc:Choice xmlns:p14="http://schemas.microsoft.com/office/powerpoint/2010/main" Requires="p14">
+      <mc:AlternateContent xmlns:mc="http://schemas.openxmlformats.org/markup-compatibility/2006" xmlns:p14="http://schemas.microsoft.com/office/powerpoint/2010/main">
+        <mc:Choice Requires="p14">
           <p:contentPart p14:bwMode="auto" r:id="rId2">
             <p14:nvContentPartPr>
               <p14:cNvPr id="8" name="Ink 7">
@@ -17183,7 +17463,7 @@
             </p14:xfrm>
           </p:contentPart>
         </mc:Choice>
-        <mc:Fallback>
+        <mc:Fallback xmlns="">
           <p:pic>
             <p:nvPicPr>
               <p:cNvPr id="8" name="Ink 7">
@@ -17234,8 +17514,8 @@
             <a:chExt cx="483840" cy="194040"/>
           </a:xfrm>
         </p:grpSpPr>
-        <mc:AlternateContent xmlns:mc="http://schemas.openxmlformats.org/markup-compatibility/2006">
-          <mc:Choice xmlns:p14="http://schemas.microsoft.com/office/powerpoint/2010/main" Requires="p14">
+        <mc:AlternateContent xmlns:mc="http://schemas.openxmlformats.org/markup-compatibility/2006" xmlns:p14="http://schemas.microsoft.com/office/powerpoint/2010/main">
+          <mc:Choice Requires="p14">
             <p:contentPart p14:bwMode="auto" r:id="rId4">
               <p14:nvContentPartPr>
                 <p14:cNvPr id="9" name="Ink 8">
@@ -17254,7 +17534,7 @@
               </p14:xfrm>
             </p:contentPart>
           </mc:Choice>
-          <mc:Fallback>
+          <mc:Fallback xmlns="">
             <p:pic>
               <p:nvPicPr>
                 <p:cNvPr id="9" name="Ink 8">
@@ -17285,8 +17565,8 @@
             </p:pic>
           </mc:Fallback>
         </mc:AlternateContent>
-        <mc:AlternateContent xmlns:mc="http://schemas.openxmlformats.org/markup-compatibility/2006">
-          <mc:Choice xmlns:p14="http://schemas.microsoft.com/office/powerpoint/2010/main" Requires="p14">
+        <mc:AlternateContent xmlns:mc="http://schemas.openxmlformats.org/markup-compatibility/2006" xmlns:p14="http://schemas.microsoft.com/office/powerpoint/2010/main">
+          <mc:Choice Requires="p14">
             <p:contentPart p14:bwMode="auto" r:id="rId6">
               <p14:nvContentPartPr>
                 <p14:cNvPr id="10" name="Ink 9">
@@ -17305,7 +17585,7 @@
               </p14:xfrm>
             </p:contentPart>
           </mc:Choice>
-          <mc:Fallback>
+          <mc:Fallback xmlns="">
             <p:pic>
               <p:nvPicPr>
                 <p:cNvPr id="10" name="Ink 9">
@@ -17336,8 +17616,8 @@
             </p:pic>
           </mc:Fallback>
         </mc:AlternateContent>
-        <mc:AlternateContent xmlns:mc="http://schemas.openxmlformats.org/markup-compatibility/2006">
-          <mc:Choice xmlns:p14="http://schemas.microsoft.com/office/powerpoint/2010/main" Requires="p14">
+        <mc:AlternateContent xmlns:mc="http://schemas.openxmlformats.org/markup-compatibility/2006" xmlns:p14="http://schemas.microsoft.com/office/powerpoint/2010/main">
+          <mc:Choice Requires="p14">
             <p:contentPart p14:bwMode="auto" r:id="rId8">
               <p14:nvContentPartPr>
                 <p14:cNvPr id="11" name="Ink 10">
@@ -17356,7 +17636,7 @@
               </p14:xfrm>
             </p:contentPart>
           </mc:Choice>
-          <mc:Fallback>
+          <mc:Fallback xmlns="">
             <p:pic>
               <p:nvPicPr>
                 <p:cNvPr id="11" name="Ink 10">
@@ -17387,8 +17667,8 @@
             </p:pic>
           </mc:Fallback>
         </mc:AlternateContent>
-        <mc:AlternateContent xmlns:mc="http://schemas.openxmlformats.org/markup-compatibility/2006">
-          <mc:Choice xmlns:p14="http://schemas.microsoft.com/office/powerpoint/2010/main" Requires="p14">
+        <mc:AlternateContent xmlns:mc="http://schemas.openxmlformats.org/markup-compatibility/2006" xmlns:p14="http://schemas.microsoft.com/office/powerpoint/2010/main">
+          <mc:Choice Requires="p14">
             <p:contentPart p14:bwMode="auto" r:id="rId10">
               <p14:nvContentPartPr>
                 <p14:cNvPr id="12" name="Ink 11">
@@ -17407,7 +17687,7 @@
               </p14:xfrm>
             </p:contentPart>
           </mc:Choice>
-          <mc:Fallback>
+          <mc:Fallback xmlns="">
             <p:pic>
               <p:nvPicPr>
                 <p:cNvPr id="12" name="Ink 11">
@@ -17438,8 +17718,8 @@
             </p:pic>
           </mc:Fallback>
         </mc:AlternateContent>
-        <mc:AlternateContent xmlns:mc="http://schemas.openxmlformats.org/markup-compatibility/2006">
-          <mc:Choice xmlns:p14="http://schemas.microsoft.com/office/powerpoint/2010/main" Requires="p14">
+        <mc:AlternateContent xmlns:mc="http://schemas.openxmlformats.org/markup-compatibility/2006" xmlns:p14="http://schemas.microsoft.com/office/powerpoint/2010/main">
+          <mc:Choice Requires="p14">
             <p:contentPart p14:bwMode="auto" r:id="rId12">
               <p14:nvContentPartPr>
                 <p14:cNvPr id="13" name="Ink 12">
@@ -17458,7 +17738,7 @@
               </p14:xfrm>
             </p:contentPart>
           </mc:Choice>
-          <mc:Fallback>
+          <mc:Fallback xmlns="">
             <p:pic>
               <p:nvPicPr>
                 <p:cNvPr id="13" name="Ink 12">
@@ -17543,8 +17823,8 @@
           </a:p>
         </p:txBody>
       </p:sp>
-      <mc:AlternateContent xmlns:mc="http://schemas.openxmlformats.org/markup-compatibility/2006">
-        <mc:Choice xmlns:p14="http://schemas.microsoft.com/office/powerpoint/2010/main" Requires="p14">
+      <mc:AlternateContent xmlns:mc="http://schemas.openxmlformats.org/markup-compatibility/2006" xmlns:p14="http://schemas.microsoft.com/office/powerpoint/2010/main">
+        <mc:Choice Requires="p14">
           <p:contentPart p14:bwMode="auto" r:id="rId14">
             <p14:nvContentPartPr>
               <p14:cNvPr id="18" name="Ink 17">
@@ -17563,7 +17843,7 @@
             </p14:xfrm>
           </p:contentPart>
         </mc:Choice>
-        <mc:Fallback>
+        <mc:Fallback xmlns="">
           <p:pic>
             <p:nvPicPr>
               <p:cNvPr id="18" name="Ink 17">
@@ -17614,8 +17894,8 @@
             <a:chExt cx="946800" cy="843480"/>
           </a:xfrm>
         </p:grpSpPr>
-        <mc:AlternateContent xmlns:mc="http://schemas.openxmlformats.org/markup-compatibility/2006">
-          <mc:Choice xmlns:p14="http://schemas.microsoft.com/office/powerpoint/2010/main" Requires="p14">
+        <mc:AlternateContent xmlns:mc="http://schemas.openxmlformats.org/markup-compatibility/2006" xmlns:p14="http://schemas.microsoft.com/office/powerpoint/2010/main">
+          <mc:Choice Requires="p14">
             <p:contentPart p14:bwMode="auto" r:id="rId16">
               <p14:nvContentPartPr>
                 <p14:cNvPr id="19" name="Ink 18">
@@ -17634,7 +17914,7 @@
               </p14:xfrm>
             </p:contentPart>
           </mc:Choice>
-          <mc:Fallback>
+          <mc:Fallback xmlns="">
             <p:pic>
               <p:nvPicPr>
                 <p:cNvPr id="19" name="Ink 18">
@@ -17665,8 +17945,8 @@
             </p:pic>
           </mc:Fallback>
         </mc:AlternateContent>
-        <mc:AlternateContent xmlns:mc="http://schemas.openxmlformats.org/markup-compatibility/2006">
-          <mc:Choice xmlns:p14="http://schemas.microsoft.com/office/powerpoint/2010/main" Requires="p14">
+        <mc:AlternateContent xmlns:mc="http://schemas.openxmlformats.org/markup-compatibility/2006" xmlns:p14="http://schemas.microsoft.com/office/powerpoint/2010/main">
+          <mc:Choice Requires="p14">
             <p:contentPart p14:bwMode="auto" r:id="rId18">
               <p14:nvContentPartPr>
                 <p14:cNvPr id="20" name="Ink 19">
@@ -17685,7 +17965,7 @@
               </p14:xfrm>
             </p:contentPart>
           </mc:Choice>
-          <mc:Fallback>
+          <mc:Fallback xmlns="">
             <p:pic>
               <p:nvPicPr>
                 <p:cNvPr id="20" name="Ink 19">
@@ -17716,8 +17996,8 @@
             </p:pic>
           </mc:Fallback>
         </mc:AlternateContent>
-        <mc:AlternateContent xmlns:mc="http://schemas.openxmlformats.org/markup-compatibility/2006">
-          <mc:Choice xmlns:p14="http://schemas.microsoft.com/office/powerpoint/2010/main" Requires="p14">
+        <mc:AlternateContent xmlns:mc="http://schemas.openxmlformats.org/markup-compatibility/2006" xmlns:p14="http://schemas.microsoft.com/office/powerpoint/2010/main">
+          <mc:Choice Requires="p14">
             <p:contentPart p14:bwMode="auto" r:id="rId20">
               <p14:nvContentPartPr>
                 <p14:cNvPr id="21" name="Ink 20">
@@ -17736,7 +18016,7 @@
               </p14:xfrm>
             </p:contentPart>
           </mc:Choice>
-          <mc:Fallback>
+          <mc:Fallback xmlns="">
             <p:pic>
               <p:nvPicPr>
                 <p:cNvPr id="21" name="Ink 20">
@@ -17767,8 +18047,8 @@
             </p:pic>
           </mc:Fallback>
         </mc:AlternateContent>
-        <mc:AlternateContent xmlns:mc="http://schemas.openxmlformats.org/markup-compatibility/2006">
-          <mc:Choice xmlns:p14="http://schemas.microsoft.com/office/powerpoint/2010/main" Requires="p14">
+        <mc:AlternateContent xmlns:mc="http://schemas.openxmlformats.org/markup-compatibility/2006" xmlns:p14="http://schemas.microsoft.com/office/powerpoint/2010/main">
+          <mc:Choice Requires="p14">
             <p:contentPart p14:bwMode="auto" r:id="rId22">
               <p14:nvContentPartPr>
                 <p14:cNvPr id="22" name="Ink 21">
@@ -17787,7 +18067,7 @@
               </p14:xfrm>
             </p:contentPart>
           </mc:Choice>
-          <mc:Fallback>
+          <mc:Fallback xmlns="">
             <p:pic>
               <p:nvPicPr>
                 <p:cNvPr id="22" name="Ink 21">
@@ -17818,8 +18098,8 @@
             </p:pic>
           </mc:Fallback>
         </mc:AlternateContent>
-        <mc:AlternateContent xmlns:mc="http://schemas.openxmlformats.org/markup-compatibility/2006">
-          <mc:Choice xmlns:p14="http://schemas.microsoft.com/office/powerpoint/2010/main" Requires="p14">
+        <mc:AlternateContent xmlns:mc="http://schemas.openxmlformats.org/markup-compatibility/2006" xmlns:p14="http://schemas.microsoft.com/office/powerpoint/2010/main">
+          <mc:Choice Requires="p14">
             <p:contentPart p14:bwMode="auto" r:id="rId24">
               <p14:nvContentPartPr>
                 <p14:cNvPr id="23" name="Ink 22">
@@ -17838,7 +18118,7 @@
               </p14:xfrm>
             </p:contentPart>
           </mc:Choice>
-          <mc:Fallback>
+          <mc:Fallback xmlns="">
             <p:pic>
               <p:nvPicPr>
                 <p:cNvPr id="23" name="Ink 22">
@@ -17869,8 +18149,8 @@
             </p:pic>
           </mc:Fallback>
         </mc:AlternateContent>
-        <mc:AlternateContent xmlns:mc="http://schemas.openxmlformats.org/markup-compatibility/2006">
-          <mc:Choice xmlns:p14="http://schemas.microsoft.com/office/powerpoint/2010/main" Requires="p14">
+        <mc:AlternateContent xmlns:mc="http://schemas.openxmlformats.org/markup-compatibility/2006" xmlns:p14="http://schemas.microsoft.com/office/powerpoint/2010/main">
+          <mc:Choice Requires="p14">
             <p:contentPart p14:bwMode="auto" r:id="rId26">
               <p14:nvContentPartPr>
                 <p14:cNvPr id="24" name="Ink 23">
@@ -17889,7 +18169,7 @@
               </p14:xfrm>
             </p:contentPart>
           </mc:Choice>
-          <mc:Fallback>
+          <mc:Fallback xmlns="">
             <p:pic>
               <p:nvPicPr>
                 <p:cNvPr id="24" name="Ink 23">
@@ -17920,8 +18200,8 @@
             </p:pic>
           </mc:Fallback>
         </mc:AlternateContent>
-        <mc:AlternateContent xmlns:mc="http://schemas.openxmlformats.org/markup-compatibility/2006">
-          <mc:Choice xmlns:p14="http://schemas.microsoft.com/office/powerpoint/2010/main" Requires="p14">
+        <mc:AlternateContent xmlns:mc="http://schemas.openxmlformats.org/markup-compatibility/2006" xmlns:p14="http://schemas.microsoft.com/office/powerpoint/2010/main">
+          <mc:Choice Requires="p14">
             <p:contentPart p14:bwMode="auto" r:id="rId28">
               <p14:nvContentPartPr>
                 <p14:cNvPr id="25" name="Ink 24">
@@ -17940,7 +18220,7 @@
               </p14:xfrm>
             </p:contentPart>
           </mc:Choice>
-          <mc:Fallback>
+          <mc:Fallback xmlns="">
             <p:pic>
               <p:nvPicPr>
                 <p:cNvPr id="25" name="Ink 24">
@@ -17971,8 +18251,8 @@
             </p:pic>
           </mc:Fallback>
         </mc:AlternateContent>
-        <mc:AlternateContent xmlns:mc="http://schemas.openxmlformats.org/markup-compatibility/2006">
-          <mc:Choice xmlns:p14="http://schemas.microsoft.com/office/powerpoint/2010/main" Requires="p14">
+        <mc:AlternateContent xmlns:mc="http://schemas.openxmlformats.org/markup-compatibility/2006" xmlns:p14="http://schemas.microsoft.com/office/powerpoint/2010/main">
+          <mc:Choice Requires="p14">
             <p:contentPart p14:bwMode="auto" r:id="rId30">
               <p14:nvContentPartPr>
                 <p14:cNvPr id="26" name="Ink 25">
@@ -17991,7 +18271,7 @@
               </p14:xfrm>
             </p:contentPart>
           </mc:Choice>
-          <mc:Fallback>
+          <mc:Fallback xmlns="">
             <p:pic>
               <p:nvPicPr>
                 <p:cNvPr id="26" name="Ink 25">
@@ -18022,8 +18302,8 @@
             </p:pic>
           </mc:Fallback>
         </mc:AlternateContent>
-        <mc:AlternateContent xmlns:mc="http://schemas.openxmlformats.org/markup-compatibility/2006">
-          <mc:Choice xmlns:p14="http://schemas.microsoft.com/office/powerpoint/2010/main" Requires="p14">
+        <mc:AlternateContent xmlns:mc="http://schemas.openxmlformats.org/markup-compatibility/2006" xmlns:p14="http://schemas.microsoft.com/office/powerpoint/2010/main">
+          <mc:Choice Requires="p14">
             <p:contentPart p14:bwMode="auto" r:id="rId32">
               <p14:nvContentPartPr>
                 <p14:cNvPr id="27" name="Ink 26">
@@ -18042,7 +18322,7 @@
               </p14:xfrm>
             </p:contentPart>
           </mc:Choice>
-          <mc:Fallback>
+          <mc:Fallback xmlns="">
             <p:pic>
               <p:nvPicPr>
                 <p:cNvPr id="27" name="Ink 26">
@@ -18073,8 +18353,8 @@
             </p:pic>
           </mc:Fallback>
         </mc:AlternateContent>
-        <mc:AlternateContent xmlns:mc="http://schemas.openxmlformats.org/markup-compatibility/2006">
-          <mc:Choice xmlns:p14="http://schemas.microsoft.com/office/powerpoint/2010/main" Requires="p14">
+        <mc:AlternateContent xmlns:mc="http://schemas.openxmlformats.org/markup-compatibility/2006" xmlns:p14="http://schemas.microsoft.com/office/powerpoint/2010/main">
+          <mc:Choice Requires="p14">
             <p:contentPart p14:bwMode="auto" r:id="rId34">
               <p14:nvContentPartPr>
                 <p14:cNvPr id="28" name="Ink 27">
@@ -18093,7 +18373,7 @@
               </p14:xfrm>
             </p:contentPart>
           </mc:Choice>
-          <mc:Fallback>
+          <mc:Fallback xmlns="">
             <p:pic>
               <p:nvPicPr>
                 <p:cNvPr id="28" name="Ink 27">
@@ -18124,8 +18404,8 @@
             </p:pic>
           </mc:Fallback>
         </mc:AlternateContent>
-        <mc:AlternateContent xmlns:mc="http://schemas.openxmlformats.org/markup-compatibility/2006">
-          <mc:Choice xmlns:p14="http://schemas.microsoft.com/office/powerpoint/2010/main" Requires="p14">
+        <mc:AlternateContent xmlns:mc="http://schemas.openxmlformats.org/markup-compatibility/2006" xmlns:p14="http://schemas.microsoft.com/office/powerpoint/2010/main">
+          <mc:Choice Requires="p14">
             <p:contentPart p14:bwMode="auto" r:id="rId36">
               <p14:nvContentPartPr>
                 <p14:cNvPr id="29" name="Ink 28">
@@ -18144,7 +18424,7 @@
               </p14:xfrm>
             </p:contentPart>
           </mc:Choice>
-          <mc:Fallback>
+          <mc:Fallback xmlns="">
             <p:pic>
               <p:nvPicPr>
                 <p:cNvPr id="29" name="Ink 28">
@@ -18175,8 +18455,8 @@
             </p:pic>
           </mc:Fallback>
         </mc:AlternateContent>
-        <mc:AlternateContent xmlns:mc="http://schemas.openxmlformats.org/markup-compatibility/2006">
-          <mc:Choice xmlns:p14="http://schemas.microsoft.com/office/powerpoint/2010/main" Requires="p14">
+        <mc:AlternateContent xmlns:mc="http://schemas.openxmlformats.org/markup-compatibility/2006" xmlns:p14="http://schemas.microsoft.com/office/powerpoint/2010/main">
+          <mc:Choice Requires="p14">
             <p:contentPart p14:bwMode="auto" r:id="rId38">
               <p14:nvContentPartPr>
                 <p14:cNvPr id="30" name="Ink 29">
@@ -18195,7 +18475,7 @@
               </p14:xfrm>
             </p:contentPart>
           </mc:Choice>
-          <mc:Fallback>
+          <mc:Fallback xmlns="">
             <p:pic>
               <p:nvPicPr>
                 <p:cNvPr id="30" name="Ink 29">
@@ -18226,8 +18506,8 @@
             </p:pic>
           </mc:Fallback>
         </mc:AlternateContent>
-        <mc:AlternateContent xmlns:mc="http://schemas.openxmlformats.org/markup-compatibility/2006">
-          <mc:Choice xmlns:p14="http://schemas.microsoft.com/office/powerpoint/2010/main" Requires="p14">
+        <mc:AlternateContent xmlns:mc="http://schemas.openxmlformats.org/markup-compatibility/2006" xmlns:p14="http://schemas.microsoft.com/office/powerpoint/2010/main">
+          <mc:Choice Requires="p14">
             <p:contentPart p14:bwMode="auto" r:id="rId40">
               <p14:nvContentPartPr>
                 <p14:cNvPr id="31" name="Ink 30">
@@ -18246,7 +18526,7 @@
               </p14:xfrm>
             </p:contentPart>
           </mc:Choice>
-          <mc:Fallback>
+          <mc:Fallback xmlns="">
             <p:pic>
               <p:nvPicPr>
                 <p:cNvPr id="31" name="Ink 30">
@@ -18277,8 +18557,8 @@
             </p:pic>
           </mc:Fallback>
         </mc:AlternateContent>
-        <mc:AlternateContent xmlns:mc="http://schemas.openxmlformats.org/markup-compatibility/2006">
-          <mc:Choice xmlns:p14="http://schemas.microsoft.com/office/powerpoint/2010/main" Requires="p14">
+        <mc:AlternateContent xmlns:mc="http://schemas.openxmlformats.org/markup-compatibility/2006" xmlns:p14="http://schemas.microsoft.com/office/powerpoint/2010/main">
+          <mc:Choice Requires="p14">
             <p:contentPart p14:bwMode="auto" r:id="rId42">
               <p14:nvContentPartPr>
                 <p14:cNvPr id="32" name="Ink 31">
@@ -18297,7 +18577,7 @@
               </p14:xfrm>
             </p:contentPart>
           </mc:Choice>
-          <mc:Fallback>
+          <mc:Fallback xmlns="">
             <p:pic>
               <p:nvPicPr>
                 <p:cNvPr id="32" name="Ink 31">
@@ -18328,8 +18608,8 @@
             </p:pic>
           </mc:Fallback>
         </mc:AlternateContent>
-        <mc:AlternateContent xmlns:mc="http://schemas.openxmlformats.org/markup-compatibility/2006">
-          <mc:Choice xmlns:p14="http://schemas.microsoft.com/office/powerpoint/2010/main" Requires="p14">
+        <mc:AlternateContent xmlns:mc="http://schemas.openxmlformats.org/markup-compatibility/2006" xmlns:p14="http://schemas.microsoft.com/office/powerpoint/2010/main">
+          <mc:Choice Requires="p14">
             <p:contentPart p14:bwMode="auto" r:id="rId44">
               <p14:nvContentPartPr>
                 <p14:cNvPr id="33" name="Ink 32">
@@ -18348,7 +18628,7 @@
               </p14:xfrm>
             </p:contentPart>
           </mc:Choice>
-          <mc:Fallback>
+          <mc:Fallback xmlns="">
             <p:pic>
               <p:nvPicPr>
                 <p:cNvPr id="33" name="Ink 32">
@@ -18400,8 +18680,8 @@
             <a:chExt cx="882720" cy="270360"/>
           </a:xfrm>
         </p:grpSpPr>
-        <mc:AlternateContent xmlns:mc="http://schemas.openxmlformats.org/markup-compatibility/2006">
-          <mc:Choice xmlns:p14="http://schemas.microsoft.com/office/powerpoint/2010/main" Requires="p14">
+        <mc:AlternateContent xmlns:mc="http://schemas.openxmlformats.org/markup-compatibility/2006" xmlns:p14="http://schemas.microsoft.com/office/powerpoint/2010/main">
+          <mc:Choice Requires="p14">
             <p:contentPart p14:bwMode="auto" r:id="rId46">
               <p14:nvContentPartPr>
                 <p14:cNvPr id="35" name="Ink 34">
@@ -18420,7 +18700,7 @@
               </p14:xfrm>
             </p:contentPart>
           </mc:Choice>
-          <mc:Fallback>
+          <mc:Fallback xmlns="">
             <p:pic>
               <p:nvPicPr>
                 <p:cNvPr id="35" name="Ink 34">
@@ -18451,8 +18731,8 @@
             </p:pic>
           </mc:Fallback>
         </mc:AlternateContent>
-        <mc:AlternateContent xmlns:mc="http://schemas.openxmlformats.org/markup-compatibility/2006">
-          <mc:Choice xmlns:p14="http://schemas.microsoft.com/office/powerpoint/2010/main" Requires="p14">
+        <mc:AlternateContent xmlns:mc="http://schemas.openxmlformats.org/markup-compatibility/2006" xmlns:p14="http://schemas.microsoft.com/office/powerpoint/2010/main">
+          <mc:Choice Requires="p14">
             <p:contentPart p14:bwMode="auto" r:id="rId48">
               <p14:nvContentPartPr>
                 <p14:cNvPr id="36" name="Ink 35">
@@ -18471,7 +18751,7 @@
               </p14:xfrm>
             </p:contentPart>
           </mc:Choice>
-          <mc:Fallback>
+          <mc:Fallback xmlns="">
             <p:pic>
               <p:nvPicPr>
                 <p:cNvPr id="36" name="Ink 35">
@@ -18502,8 +18782,8 @@
             </p:pic>
           </mc:Fallback>
         </mc:AlternateContent>
-        <mc:AlternateContent xmlns:mc="http://schemas.openxmlformats.org/markup-compatibility/2006">
-          <mc:Choice xmlns:p14="http://schemas.microsoft.com/office/powerpoint/2010/main" Requires="p14">
+        <mc:AlternateContent xmlns:mc="http://schemas.openxmlformats.org/markup-compatibility/2006" xmlns:p14="http://schemas.microsoft.com/office/powerpoint/2010/main">
+          <mc:Choice Requires="p14">
             <p:contentPart p14:bwMode="auto" r:id="rId50">
               <p14:nvContentPartPr>
                 <p14:cNvPr id="37" name="Ink 36">
@@ -18522,7 +18802,7 @@
               </p14:xfrm>
             </p:contentPart>
           </mc:Choice>
-          <mc:Fallback>
+          <mc:Fallback xmlns="">
             <p:pic>
               <p:nvPicPr>
                 <p:cNvPr id="37" name="Ink 36">
@@ -18553,8 +18833,8 @@
             </p:pic>
           </mc:Fallback>
         </mc:AlternateContent>
-        <mc:AlternateContent xmlns:mc="http://schemas.openxmlformats.org/markup-compatibility/2006">
-          <mc:Choice xmlns:p14="http://schemas.microsoft.com/office/powerpoint/2010/main" Requires="p14">
+        <mc:AlternateContent xmlns:mc="http://schemas.openxmlformats.org/markup-compatibility/2006" xmlns:p14="http://schemas.microsoft.com/office/powerpoint/2010/main">
+          <mc:Choice Requires="p14">
             <p:contentPart p14:bwMode="auto" r:id="rId52">
               <p14:nvContentPartPr>
                 <p14:cNvPr id="38" name="Ink 37">
@@ -18573,7 +18853,7 @@
               </p14:xfrm>
             </p:contentPart>
           </mc:Choice>
-          <mc:Fallback>
+          <mc:Fallback xmlns="">
             <p:pic>
               <p:nvPicPr>
                 <p:cNvPr id="38" name="Ink 37">
@@ -18604,8 +18884,8 @@
             </p:pic>
           </mc:Fallback>
         </mc:AlternateContent>
-        <mc:AlternateContent xmlns:mc="http://schemas.openxmlformats.org/markup-compatibility/2006">
-          <mc:Choice xmlns:p14="http://schemas.microsoft.com/office/powerpoint/2010/main" Requires="p14">
+        <mc:AlternateContent xmlns:mc="http://schemas.openxmlformats.org/markup-compatibility/2006" xmlns:p14="http://schemas.microsoft.com/office/powerpoint/2010/main">
+          <mc:Choice Requires="p14">
             <p:contentPart p14:bwMode="auto" r:id="rId54">
               <p14:nvContentPartPr>
                 <p14:cNvPr id="39" name="Ink 38">
@@ -18624,7 +18904,7 @@
               </p14:xfrm>
             </p:contentPart>
           </mc:Choice>
-          <mc:Fallback>
+          <mc:Fallback xmlns="">
             <p:pic>
               <p:nvPicPr>
                 <p:cNvPr id="39" name="Ink 38">
@@ -18655,8 +18935,8 @@
             </p:pic>
           </mc:Fallback>
         </mc:AlternateContent>
-        <mc:AlternateContent xmlns:mc="http://schemas.openxmlformats.org/markup-compatibility/2006">
-          <mc:Choice xmlns:p14="http://schemas.microsoft.com/office/powerpoint/2010/main" Requires="p14">
+        <mc:AlternateContent xmlns:mc="http://schemas.openxmlformats.org/markup-compatibility/2006" xmlns:p14="http://schemas.microsoft.com/office/powerpoint/2010/main">
+          <mc:Choice Requires="p14">
             <p:contentPart p14:bwMode="auto" r:id="rId56">
               <p14:nvContentPartPr>
                 <p14:cNvPr id="40" name="Ink 39">
@@ -18675,7 +18955,7 @@
               </p14:xfrm>
             </p:contentPart>
           </mc:Choice>
-          <mc:Fallback>
+          <mc:Fallback xmlns="">
             <p:pic>
               <p:nvPicPr>
                 <p:cNvPr id="40" name="Ink 39">
@@ -18706,8 +18986,8 @@
             </p:pic>
           </mc:Fallback>
         </mc:AlternateContent>
-        <mc:AlternateContent xmlns:mc="http://schemas.openxmlformats.org/markup-compatibility/2006">
-          <mc:Choice xmlns:p14="http://schemas.microsoft.com/office/powerpoint/2010/main" Requires="p14">
+        <mc:AlternateContent xmlns:mc="http://schemas.openxmlformats.org/markup-compatibility/2006" xmlns:p14="http://schemas.microsoft.com/office/powerpoint/2010/main">
+          <mc:Choice Requires="p14">
             <p:contentPart p14:bwMode="auto" r:id="rId58">
               <p14:nvContentPartPr>
                 <p14:cNvPr id="41" name="Ink 40">
@@ -18726,7 +19006,7 @@
               </p14:xfrm>
             </p:contentPart>
           </mc:Choice>
-          <mc:Fallback>
+          <mc:Fallback xmlns="">
             <p:pic>
               <p:nvPicPr>
                 <p:cNvPr id="41" name="Ink 40">
@@ -18778,8 +19058,8 @@
             <a:chExt cx="1219320" cy="236880"/>
           </a:xfrm>
         </p:grpSpPr>
-        <mc:AlternateContent xmlns:mc="http://schemas.openxmlformats.org/markup-compatibility/2006">
-          <mc:Choice xmlns:p14="http://schemas.microsoft.com/office/powerpoint/2010/main" Requires="p14">
+        <mc:AlternateContent xmlns:mc="http://schemas.openxmlformats.org/markup-compatibility/2006" xmlns:p14="http://schemas.microsoft.com/office/powerpoint/2010/main">
+          <mc:Choice Requires="p14">
             <p:contentPart p14:bwMode="auto" r:id="rId60">
               <p14:nvContentPartPr>
                 <p14:cNvPr id="43" name="Ink 42">
@@ -18798,7 +19078,7 @@
               </p14:xfrm>
             </p:contentPart>
           </mc:Choice>
-          <mc:Fallback>
+          <mc:Fallback xmlns="">
             <p:pic>
               <p:nvPicPr>
                 <p:cNvPr id="43" name="Ink 42">
@@ -18829,8 +19109,8 @@
             </p:pic>
           </mc:Fallback>
         </mc:AlternateContent>
-        <mc:AlternateContent xmlns:mc="http://schemas.openxmlformats.org/markup-compatibility/2006">
-          <mc:Choice xmlns:p14="http://schemas.microsoft.com/office/powerpoint/2010/main" Requires="p14">
+        <mc:AlternateContent xmlns:mc="http://schemas.openxmlformats.org/markup-compatibility/2006" xmlns:p14="http://schemas.microsoft.com/office/powerpoint/2010/main">
+          <mc:Choice Requires="p14">
             <p:contentPart p14:bwMode="auto" r:id="rId62">
               <p14:nvContentPartPr>
                 <p14:cNvPr id="44" name="Ink 43">
@@ -18849,7 +19129,7 @@
               </p14:xfrm>
             </p:contentPart>
           </mc:Choice>
-          <mc:Fallback>
+          <mc:Fallback xmlns="">
             <p:pic>
               <p:nvPicPr>
                 <p:cNvPr id="44" name="Ink 43">
@@ -18880,8 +19160,8 @@
             </p:pic>
           </mc:Fallback>
         </mc:AlternateContent>
-        <mc:AlternateContent xmlns:mc="http://schemas.openxmlformats.org/markup-compatibility/2006">
-          <mc:Choice xmlns:p14="http://schemas.microsoft.com/office/powerpoint/2010/main" Requires="p14">
+        <mc:AlternateContent xmlns:mc="http://schemas.openxmlformats.org/markup-compatibility/2006" xmlns:p14="http://schemas.microsoft.com/office/powerpoint/2010/main">
+          <mc:Choice Requires="p14">
             <p:contentPart p14:bwMode="auto" r:id="rId64">
               <p14:nvContentPartPr>
                 <p14:cNvPr id="45" name="Ink 44">
@@ -18900,7 +19180,7 @@
               </p14:xfrm>
             </p:contentPart>
           </mc:Choice>
-          <mc:Fallback>
+          <mc:Fallback xmlns="">
             <p:pic>
               <p:nvPicPr>
                 <p:cNvPr id="45" name="Ink 44">
@@ -18931,8 +19211,8 @@
             </p:pic>
           </mc:Fallback>
         </mc:AlternateContent>
-        <mc:AlternateContent xmlns:mc="http://schemas.openxmlformats.org/markup-compatibility/2006">
-          <mc:Choice xmlns:p14="http://schemas.microsoft.com/office/powerpoint/2010/main" Requires="p14">
+        <mc:AlternateContent xmlns:mc="http://schemas.openxmlformats.org/markup-compatibility/2006" xmlns:p14="http://schemas.microsoft.com/office/powerpoint/2010/main">
+          <mc:Choice Requires="p14">
             <p:contentPart p14:bwMode="auto" r:id="rId66">
               <p14:nvContentPartPr>
                 <p14:cNvPr id="46" name="Ink 45">
@@ -18951,7 +19231,7 @@
               </p14:xfrm>
             </p:contentPart>
           </mc:Choice>
-          <mc:Fallback>
+          <mc:Fallback xmlns="">
             <p:pic>
               <p:nvPicPr>
                 <p:cNvPr id="46" name="Ink 45">
@@ -18982,8 +19262,8 @@
             </p:pic>
           </mc:Fallback>
         </mc:AlternateContent>
-        <mc:AlternateContent xmlns:mc="http://schemas.openxmlformats.org/markup-compatibility/2006">
-          <mc:Choice xmlns:p14="http://schemas.microsoft.com/office/powerpoint/2010/main" Requires="p14">
+        <mc:AlternateContent xmlns:mc="http://schemas.openxmlformats.org/markup-compatibility/2006" xmlns:p14="http://schemas.microsoft.com/office/powerpoint/2010/main">
+          <mc:Choice Requires="p14">
             <p:contentPart p14:bwMode="auto" r:id="rId68">
               <p14:nvContentPartPr>
                 <p14:cNvPr id="47" name="Ink 46">
@@ -19002,7 +19282,7 @@
               </p14:xfrm>
             </p:contentPart>
           </mc:Choice>
-          <mc:Fallback>
+          <mc:Fallback xmlns="">
             <p:pic>
               <p:nvPicPr>
                 <p:cNvPr id="47" name="Ink 46">
@@ -19033,8 +19313,8 @@
             </p:pic>
           </mc:Fallback>
         </mc:AlternateContent>
-        <mc:AlternateContent xmlns:mc="http://schemas.openxmlformats.org/markup-compatibility/2006">
-          <mc:Choice xmlns:p14="http://schemas.microsoft.com/office/powerpoint/2010/main" Requires="p14">
+        <mc:AlternateContent xmlns:mc="http://schemas.openxmlformats.org/markup-compatibility/2006" xmlns:p14="http://schemas.microsoft.com/office/powerpoint/2010/main">
+          <mc:Choice Requires="p14">
             <p:contentPart p14:bwMode="auto" r:id="rId70">
               <p14:nvContentPartPr>
                 <p14:cNvPr id="48" name="Ink 47">
@@ -19053,7 +19333,7 @@
               </p14:xfrm>
             </p:contentPart>
           </mc:Choice>
-          <mc:Fallback>
+          <mc:Fallback xmlns="">
             <p:pic>
               <p:nvPicPr>
                 <p:cNvPr id="48" name="Ink 47">
@@ -19084,8 +19364,8 @@
             </p:pic>
           </mc:Fallback>
         </mc:AlternateContent>
-        <mc:AlternateContent xmlns:mc="http://schemas.openxmlformats.org/markup-compatibility/2006">
-          <mc:Choice xmlns:p14="http://schemas.microsoft.com/office/powerpoint/2010/main" Requires="p14">
+        <mc:AlternateContent xmlns:mc="http://schemas.openxmlformats.org/markup-compatibility/2006" xmlns:p14="http://schemas.microsoft.com/office/powerpoint/2010/main">
+          <mc:Choice Requires="p14">
             <p:contentPart p14:bwMode="auto" r:id="rId72">
               <p14:nvContentPartPr>
                 <p14:cNvPr id="49" name="Ink 48">
@@ -19104,7 +19384,7 @@
               </p14:xfrm>
             </p:contentPart>
           </mc:Choice>
-          <mc:Fallback>
+          <mc:Fallback xmlns="">
             <p:pic>
               <p:nvPicPr>
                 <p:cNvPr id="49" name="Ink 48">
@@ -19135,8 +19415,8 @@
             </p:pic>
           </mc:Fallback>
         </mc:AlternateContent>
-        <mc:AlternateContent xmlns:mc="http://schemas.openxmlformats.org/markup-compatibility/2006">
-          <mc:Choice xmlns:p14="http://schemas.microsoft.com/office/powerpoint/2010/main" Requires="p14">
+        <mc:AlternateContent xmlns:mc="http://schemas.openxmlformats.org/markup-compatibility/2006" xmlns:p14="http://schemas.microsoft.com/office/powerpoint/2010/main">
+          <mc:Choice Requires="p14">
             <p:contentPart p14:bwMode="auto" r:id="rId74">
               <p14:nvContentPartPr>
                 <p14:cNvPr id="50" name="Ink 49">
@@ -19155,7 +19435,7 @@
               </p14:xfrm>
             </p:contentPart>
           </mc:Choice>
-          <mc:Fallback>
+          <mc:Fallback xmlns="">
             <p:pic>
               <p:nvPicPr>
                 <p:cNvPr id="50" name="Ink 49">
@@ -19186,8 +19466,8 @@
             </p:pic>
           </mc:Fallback>
         </mc:AlternateContent>
-        <mc:AlternateContent xmlns:mc="http://schemas.openxmlformats.org/markup-compatibility/2006">
-          <mc:Choice xmlns:p14="http://schemas.microsoft.com/office/powerpoint/2010/main" Requires="p14">
+        <mc:AlternateContent xmlns:mc="http://schemas.openxmlformats.org/markup-compatibility/2006" xmlns:p14="http://schemas.microsoft.com/office/powerpoint/2010/main">
+          <mc:Choice Requires="p14">
             <p:contentPart p14:bwMode="auto" r:id="rId76">
               <p14:nvContentPartPr>
                 <p14:cNvPr id="51" name="Ink 50">
@@ -19206,7 +19486,7 @@
               </p14:xfrm>
             </p:contentPart>
           </mc:Choice>
-          <mc:Fallback>
+          <mc:Fallback xmlns="">
             <p:pic>
               <p:nvPicPr>
                 <p:cNvPr id="51" name="Ink 50">
@@ -19237,8 +19517,8 @@
             </p:pic>
           </mc:Fallback>
         </mc:AlternateContent>
-        <mc:AlternateContent xmlns:mc="http://schemas.openxmlformats.org/markup-compatibility/2006">
-          <mc:Choice xmlns:p14="http://schemas.microsoft.com/office/powerpoint/2010/main" Requires="p14">
+        <mc:AlternateContent xmlns:mc="http://schemas.openxmlformats.org/markup-compatibility/2006" xmlns:p14="http://schemas.microsoft.com/office/powerpoint/2010/main">
+          <mc:Choice Requires="p14">
             <p:contentPart p14:bwMode="auto" r:id="rId78">
               <p14:nvContentPartPr>
                 <p14:cNvPr id="52" name="Ink 51">
@@ -19257,7 +19537,7 @@
               </p14:xfrm>
             </p:contentPart>
           </mc:Choice>
-          <mc:Fallback>
+          <mc:Fallback xmlns="">
             <p:pic>
               <p:nvPicPr>
                 <p:cNvPr id="52" name="Ink 51">
@@ -19288,8 +19568,8 @@
             </p:pic>
           </mc:Fallback>
         </mc:AlternateContent>
-        <mc:AlternateContent xmlns:mc="http://schemas.openxmlformats.org/markup-compatibility/2006">
-          <mc:Choice xmlns:p14="http://schemas.microsoft.com/office/powerpoint/2010/main" Requires="p14">
+        <mc:AlternateContent xmlns:mc="http://schemas.openxmlformats.org/markup-compatibility/2006" xmlns:p14="http://schemas.microsoft.com/office/powerpoint/2010/main">
+          <mc:Choice Requires="p14">
             <p:contentPart p14:bwMode="auto" r:id="rId80">
               <p14:nvContentPartPr>
                 <p14:cNvPr id="53" name="Ink 52">
@@ -19308,7 +19588,7 @@
               </p14:xfrm>
             </p:contentPart>
           </mc:Choice>
-          <mc:Fallback>
+          <mc:Fallback xmlns="">
             <p:pic>
               <p:nvPicPr>
                 <p:cNvPr id="53" name="Ink 52">
@@ -19339,8 +19619,8 @@
             </p:pic>
           </mc:Fallback>
         </mc:AlternateContent>
-        <mc:AlternateContent xmlns:mc="http://schemas.openxmlformats.org/markup-compatibility/2006">
-          <mc:Choice xmlns:p14="http://schemas.microsoft.com/office/powerpoint/2010/main" Requires="p14">
+        <mc:AlternateContent xmlns:mc="http://schemas.openxmlformats.org/markup-compatibility/2006" xmlns:p14="http://schemas.microsoft.com/office/powerpoint/2010/main">
+          <mc:Choice Requires="p14">
             <p:contentPart p14:bwMode="auto" r:id="rId82">
               <p14:nvContentPartPr>
                 <p14:cNvPr id="54" name="Ink 53">
@@ -19359,7 +19639,7 @@
               </p14:xfrm>
             </p:contentPart>
           </mc:Choice>
-          <mc:Fallback>
+          <mc:Fallback xmlns="">
             <p:pic>
               <p:nvPicPr>
                 <p:cNvPr id="54" name="Ink 53">
@@ -19390,8 +19670,8 @@
             </p:pic>
           </mc:Fallback>
         </mc:AlternateContent>
-        <mc:AlternateContent xmlns:mc="http://schemas.openxmlformats.org/markup-compatibility/2006">
-          <mc:Choice xmlns:p14="http://schemas.microsoft.com/office/powerpoint/2010/main" Requires="p14">
+        <mc:AlternateContent xmlns:mc="http://schemas.openxmlformats.org/markup-compatibility/2006" xmlns:p14="http://schemas.microsoft.com/office/powerpoint/2010/main">
+          <mc:Choice Requires="p14">
             <p:contentPart p14:bwMode="auto" r:id="rId84">
               <p14:nvContentPartPr>
                 <p14:cNvPr id="55" name="Ink 54">
@@ -19410,7 +19690,7 @@
               </p14:xfrm>
             </p:contentPart>
           </mc:Choice>
-          <mc:Fallback>
+          <mc:Fallback xmlns="">
             <p:pic>
               <p:nvPicPr>
                 <p:cNvPr id="55" name="Ink 54">
@@ -19442,8 +19722,8 @@
           </mc:Fallback>
         </mc:AlternateContent>
       </p:grpSp>
-      <mc:AlternateContent xmlns:mc="http://schemas.openxmlformats.org/markup-compatibility/2006">
-        <mc:Choice xmlns:p14="http://schemas.microsoft.com/office/powerpoint/2010/main" Requires="p14">
+      <mc:AlternateContent xmlns:mc="http://schemas.openxmlformats.org/markup-compatibility/2006" xmlns:p14="http://schemas.microsoft.com/office/powerpoint/2010/main">
+        <mc:Choice Requires="p14">
           <p:contentPart p14:bwMode="auto" r:id="rId86">
             <p14:nvContentPartPr>
               <p14:cNvPr id="58" name="Ink 57">
@@ -19462,7 +19742,7 @@
             </p14:xfrm>
           </p:contentPart>
         </mc:Choice>
-        <mc:Fallback>
+        <mc:Fallback xmlns="">
           <p:pic>
             <p:nvPicPr>
               <p:cNvPr id="58" name="Ink 57">
@@ -19513,8 +19793,8 @@
             <a:chExt cx="949320" cy="211320"/>
           </a:xfrm>
         </p:grpSpPr>
-        <mc:AlternateContent xmlns:mc="http://schemas.openxmlformats.org/markup-compatibility/2006">
-          <mc:Choice xmlns:p14="http://schemas.microsoft.com/office/powerpoint/2010/main" Requires="p14">
+        <mc:AlternateContent xmlns:mc="http://schemas.openxmlformats.org/markup-compatibility/2006" xmlns:p14="http://schemas.microsoft.com/office/powerpoint/2010/main">
+          <mc:Choice Requires="p14">
             <p:contentPart p14:bwMode="auto" r:id="rId88">
               <p14:nvContentPartPr>
                 <p14:cNvPr id="59" name="Ink 58">
@@ -19533,7 +19813,7 @@
               </p14:xfrm>
             </p:contentPart>
           </mc:Choice>
-          <mc:Fallback>
+          <mc:Fallback xmlns="">
             <p:pic>
               <p:nvPicPr>
                 <p:cNvPr id="59" name="Ink 58">
@@ -19564,8 +19844,8 @@
             </p:pic>
           </mc:Fallback>
         </mc:AlternateContent>
-        <mc:AlternateContent xmlns:mc="http://schemas.openxmlformats.org/markup-compatibility/2006">
-          <mc:Choice xmlns:p14="http://schemas.microsoft.com/office/powerpoint/2010/main" Requires="p14">
+        <mc:AlternateContent xmlns:mc="http://schemas.openxmlformats.org/markup-compatibility/2006" xmlns:p14="http://schemas.microsoft.com/office/powerpoint/2010/main">
+          <mc:Choice Requires="p14">
             <p:contentPart p14:bwMode="auto" r:id="rId90">
               <p14:nvContentPartPr>
                 <p14:cNvPr id="60" name="Ink 59">
@@ -19584,7 +19864,7 @@
               </p14:xfrm>
             </p:contentPart>
           </mc:Choice>
-          <mc:Fallback>
+          <mc:Fallback xmlns="">
             <p:pic>
               <p:nvPicPr>
                 <p:cNvPr id="60" name="Ink 59">
@@ -19615,8 +19895,8 @@
             </p:pic>
           </mc:Fallback>
         </mc:AlternateContent>
-        <mc:AlternateContent xmlns:mc="http://schemas.openxmlformats.org/markup-compatibility/2006">
-          <mc:Choice xmlns:p14="http://schemas.microsoft.com/office/powerpoint/2010/main" Requires="p14">
+        <mc:AlternateContent xmlns:mc="http://schemas.openxmlformats.org/markup-compatibility/2006" xmlns:p14="http://schemas.microsoft.com/office/powerpoint/2010/main">
+          <mc:Choice Requires="p14">
             <p:contentPart p14:bwMode="auto" r:id="rId92">
               <p14:nvContentPartPr>
                 <p14:cNvPr id="61" name="Ink 60">
@@ -19635,7 +19915,7 @@
               </p14:xfrm>
             </p:contentPart>
           </mc:Choice>
-          <mc:Fallback>
+          <mc:Fallback xmlns="">
             <p:pic>
               <p:nvPicPr>
                 <p:cNvPr id="61" name="Ink 60">
@@ -19666,8 +19946,8 @@
             </p:pic>
           </mc:Fallback>
         </mc:AlternateContent>
-        <mc:AlternateContent xmlns:mc="http://schemas.openxmlformats.org/markup-compatibility/2006">
-          <mc:Choice xmlns:p14="http://schemas.microsoft.com/office/powerpoint/2010/main" Requires="p14">
+        <mc:AlternateContent xmlns:mc="http://schemas.openxmlformats.org/markup-compatibility/2006" xmlns:p14="http://schemas.microsoft.com/office/powerpoint/2010/main">
+          <mc:Choice Requires="p14">
             <p:contentPart p14:bwMode="auto" r:id="rId94">
               <p14:nvContentPartPr>
                 <p14:cNvPr id="62" name="Ink 61">
@@ -19686,7 +19966,7 @@
               </p14:xfrm>
             </p:contentPart>
           </mc:Choice>
-          <mc:Fallback>
+          <mc:Fallback xmlns="">
             <p:pic>
               <p:nvPicPr>
                 <p:cNvPr id="62" name="Ink 61">
@@ -19717,8 +19997,8 @@
             </p:pic>
           </mc:Fallback>
         </mc:AlternateContent>
-        <mc:AlternateContent xmlns:mc="http://schemas.openxmlformats.org/markup-compatibility/2006">
-          <mc:Choice xmlns:p14="http://schemas.microsoft.com/office/powerpoint/2010/main" Requires="p14">
+        <mc:AlternateContent xmlns:mc="http://schemas.openxmlformats.org/markup-compatibility/2006" xmlns:p14="http://schemas.microsoft.com/office/powerpoint/2010/main">
+          <mc:Choice Requires="p14">
             <p:contentPart p14:bwMode="auto" r:id="rId96">
               <p14:nvContentPartPr>
                 <p14:cNvPr id="63" name="Ink 62">
@@ -19737,7 +20017,7 @@
               </p14:xfrm>
             </p:contentPart>
           </mc:Choice>
-          <mc:Fallback>
+          <mc:Fallback xmlns="">
             <p:pic>
               <p:nvPicPr>
                 <p:cNvPr id="63" name="Ink 62">
@@ -19769,8 +20049,8 @@
           </mc:Fallback>
         </mc:AlternateContent>
       </p:grpSp>
-      <mc:AlternateContent xmlns:mc="http://schemas.openxmlformats.org/markup-compatibility/2006">
-        <mc:Choice xmlns:p14="http://schemas.microsoft.com/office/powerpoint/2010/main" Requires="p14">
+      <mc:AlternateContent xmlns:mc="http://schemas.openxmlformats.org/markup-compatibility/2006" xmlns:p14="http://schemas.microsoft.com/office/powerpoint/2010/main">
+        <mc:Choice Requires="p14">
           <p:contentPart p14:bwMode="auto" r:id="rId98">
             <p14:nvContentPartPr>
               <p14:cNvPr id="66" name="Ink 65">
@@ -19789,7 +20069,7 @@
             </p14:xfrm>
           </p:contentPart>
         </mc:Choice>
-        <mc:Fallback>
+        <mc:Fallback xmlns="">
           <p:pic>
             <p:nvPicPr>
               <p:cNvPr id="66" name="Ink 65">
@@ -19820,8 +20100,8 @@
           </p:pic>
         </mc:Fallback>
       </mc:AlternateContent>
-      <mc:AlternateContent xmlns:mc="http://schemas.openxmlformats.org/markup-compatibility/2006">
-        <mc:Choice xmlns:p14="http://schemas.microsoft.com/office/powerpoint/2010/main" Requires="p14">
+      <mc:AlternateContent xmlns:mc="http://schemas.openxmlformats.org/markup-compatibility/2006" xmlns:p14="http://schemas.microsoft.com/office/powerpoint/2010/main">
+        <mc:Choice Requires="p14">
           <p:contentPart p14:bwMode="auto" r:id="rId100">
             <p14:nvContentPartPr>
               <p14:cNvPr id="68" name="Ink 67">
@@ -19840,7 +20120,7 @@
             </p14:xfrm>
           </p:contentPart>
         </mc:Choice>
-        <mc:Fallback>
+        <mc:Fallback xmlns="">
           <p:pic>
             <p:nvPicPr>
               <p:cNvPr id="68" name="Ink 67">
@@ -19891,8 +20171,8 @@
             <a:chExt cx="542520" cy="190080"/>
           </a:xfrm>
         </p:grpSpPr>
-        <mc:AlternateContent xmlns:mc="http://schemas.openxmlformats.org/markup-compatibility/2006">
-          <mc:Choice xmlns:p14="http://schemas.microsoft.com/office/powerpoint/2010/main" Requires="p14">
+        <mc:AlternateContent xmlns:mc="http://schemas.openxmlformats.org/markup-compatibility/2006" xmlns:p14="http://schemas.microsoft.com/office/powerpoint/2010/main">
+          <mc:Choice Requires="p14">
             <p:contentPart p14:bwMode="auto" r:id="rId102">
               <p14:nvContentPartPr>
                 <p14:cNvPr id="69" name="Ink 68">
@@ -19911,7 +20191,7 @@
               </p14:xfrm>
             </p:contentPart>
           </mc:Choice>
-          <mc:Fallback>
+          <mc:Fallback xmlns="">
             <p:pic>
               <p:nvPicPr>
                 <p:cNvPr id="69" name="Ink 68">
@@ -19942,8 +20222,8 @@
             </p:pic>
           </mc:Fallback>
         </mc:AlternateContent>
-        <mc:AlternateContent xmlns:mc="http://schemas.openxmlformats.org/markup-compatibility/2006">
-          <mc:Choice xmlns:p14="http://schemas.microsoft.com/office/powerpoint/2010/main" Requires="p14">
+        <mc:AlternateContent xmlns:mc="http://schemas.openxmlformats.org/markup-compatibility/2006" xmlns:p14="http://schemas.microsoft.com/office/powerpoint/2010/main">
+          <mc:Choice Requires="p14">
             <p:contentPart p14:bwMode="auto" r:id="rId104">
               <p14:nvContentPartPr>
                 <p14:cNvPr id="70" name="Ink 69">
@@ -19962,7 +20242,7 @@
               </p14:xfrm>
             </p:contentPart>
           </mc:Choice>
-          <mc:Fallback>
+          <mc:Fallback xmlns="">
             <p:pic>
               <p:nvPicPr>
                 <p:cNvPr id="70" name="Ink 69">
@@ -19993,8 +20273,8 @@
             </p:pic>
           </mc:Fallback>
         </mc:AlternateContent>
-        <mc:AlternateContent xmlns:mc="http://schemas.openxmlformats.org/markup-compatibility/2006">
-          <mc:Choice xmlns:p14="http://schemas.microsoft.com/office/powerpoint/2010/main" Requires="p14">
+        <mc:AlternateContent xmlns:mc="http://schemas.openxmlformats.org/markup-compatibility/2006" xmlns:p14="http://schemas.microsoft.com/office/powerpoint/2010/main">
+          <mc:Choice Requires="p14">
             <p:contentPart p14:bwMode="auto" r:id="rId106">
               <p14:nvContentPartPr>
                 <p14:cNvPr id="71" name="Ink 70">
@@ -20013,7 +20293,7 @@
               </p14:xfrm>
             </p:contentPart>
           </mc:Choice>
-          <mc:Fallback>
+          <mc:Fallback xmlns="">
             <p:pic>
               <p:nvPicPr>
                 <p:cNvPr id="71" name="Ink 70">
@@ -20044,8 +20324,8 @@
             </p:pic>
           </mc:Fallback>
         </mc:AlternateContent>
-        <mc:AlternateContent xmlns:mc="http://schemas.openxmlformats.org/markup-compatibility/2006">
-          <mc:Choice xmlns:p14="http://schemas.microsoft.com/office/powerpoint/2010/main" Requires="p14">
+        <mc:AlternateContent xmlns:mc="http://schemas.openxmlformats.org/markup-compatibility/2006" xmlns:p14="http://schemas.microsoft.com/office/powerpoint/2010/main">
+          <mc:Choice Requires="p14">
             <p:contentPart p14:bwMode="auto" r:id="rId108">
               <p14:nvContentPartPr>
                 <p14:cNvPr id="72" name="Ink 71">
@@ -20064,7 +20344,7 @@
               </p14:xfrm>
             </p:contentPart>
           </mc:Choice>
-          <mc:Fallback>
+          <mc:Fallback xmlns="">
             <p:pic>
               <p:nvPicPr>
                 <p:cNvPr id="72" name="Ink 71">
@@ -20096,8 +20376,8 @@
           </mc:Fallback>
         </mc:AlternateContent>
       </p:grpSp>
-      <mc:AlternateContent xmlns:mc="http://schemas.openxmlformats.org/markup-compatibility/2006">
-        <mc:Choice xmlns:p14="http://schemas.microsoft.com/office/powerpoint/2010/main" Requires="p14">
+      <mc:AlternateContent xmlns:mc="http://schemas.openxmlformats.org/markup-compatibility/2006" xmlns:p14="http://schemas.microsoft.com/office/powerpoint/2010/main">
+        <mc:Choice Requires="p14">
           <p:contentPart p14:bwMode="auto" r:id="rId110">
             <p14:nvContentPartPr>
               <p14:cNvPr id="83" name="Ink 82">
@@ -20116,7 +20396,7 @@
             </p14:xfrm>
           </p:contentPart>
         </mc:Choice>
-        <mc:Fallback>
+        <mc:Fallback xmlns="">
           <p:pic>
             <p:nvPicPr>
               <p:cNvPr id="83" name="Ink 82">
@@ -20167,8 +20447,8 @@
             <a:chExt cx="1264680" cy="503640"/>
           </a:xfrm>
         </p:grpSpPr>
-        <mc:AlternateContent xmlns:mc="http://schemas.openxmlformats.org/markup-compatibility/2006">
-          <mc:Choice xmlns:p14="http://schemas.microsoft.com/office/powerpoint/2010/main" Requires="p14">
+        <mc:AlternateContent xmlns:mc="http://schemas.openxmlformats.org/markup-compatibility/2006" xmlns:p14="http://schemas.microsoft.com/office/powerpoint/2010/main">
+          <mc:Choice Requires="p14">
             <p:contentPart p14:bwMode="auto" r:id="rId112">
               <p14:nvContentPartPr>
                 <p14:cNvPr id="74" name="Ink 73">
@@ -20187,7 +20467,7 @@
               </p14:xfrm>
             </p:contentPart>
           </mc:Choice>
-          <mc:Fallback>
+          <mc:Fallback xmlns="">
             <p:pic>
               <p:nvPicPr>
                 <p:cNvPr id="74" name="Ink 73">
@@ -20218,8 +20498,8 @@
             </p:pic>
           </mc:Fallback>
         </mc:AlternateContent>
-        <mc:AlternateContent xmlns:mc="http://schemas.openxmlformats.org/markup-compatibility/2006">
-          <mc:Choice xmlns:p14="http://schemas.microsoft.com/office/powerpoint/2010/main" Requires="p14">
+        <mc:AlternateContent xmlns:mc="http://schemas.openxmlformats.org/markup-compatibility/2006" xmlns:p14="http://schemas.microsoft.com/office/powerpoint/2010/main">
+          <mc:Choice Requires="p14">
             <p:contentPart p14:bwMode="auto" r:id="rId114">
               <p14:nvContentPartPr>
                 <p14:cNvPr id="75" name="Ink 74">
@@ -20238,7 +20518,7 @@
               </p14:xfrm>
             </p:contentPart>
           </mc:Choice>
-          <mc:Fallback>
+          <mc:Fallback xmlns="">
             <p:pic>
               <p:nvPicPr>
                 <p:cNvPr id="75" name="Ink 74">
@@ -20269,8 +20549,8 @@
             </p:pic>
           </mc:Fallback>
         </mc:AlternateContent>
-        <mc:AlternateContent xmlns:mc="http://schemas.openxmlformats.org/markup-compatibility/2006">
-          <mc:Choice xmlns:p14="http://schemas.microsoft.com/office/powerpoint/2010/main" Requires="p14">
+        <mc:AlternateContent xmlns:mc="http://schemas.openxmlformats.org/markup-compatibility/2006" xmlns:p14="http://schemas.microsoft.com/office/powerpoint/2010/main">
+          <mc:Choice Requires="p14">
             <p:contentPart p14:bwMode="auto" r:id="rId116">
               <p14:nvContentPartPr>
                 <p14:cNvPr id="77" name="Ink 76">
@@ -20289,7 +20569,7 @@
               </p14:xfrm>
             </p:contentPart>
           </mc:Choice>
-          <mc:Fallback>
+          <mc:Fallback xmlns="">
             <p:pic>
               <p:nvPicPr>
                 <p:cNvPr id="77" name="Ink 76">
@@ -20320,8 +20600,8 @@
             </p:pic>
           </mc:Fallback>
         </mc:AlternateContent>
-        <mc:AlternateContent xmlns:mc="http://schemas.openxmlformats.org/markup-compatibility/2006">
-          <mc:Choice xmlns:p14="http://schemas.microsoft.com/office/powerpoint/2010/main" Requires="p14">
+        <mc:AlternateContent xmlns:mc="http://schemas.openxmlformats.org/markup-compatibility/2006" xmlns:p14="http://schemas.microsoft.com/office/powerpoint/2010/main">
+          <mc:Choice Requires="p14">
             <p:contentPart p14:bwMode="auto" r:id="rId118">
               <p14:nvContentPartPr>
                 <p14:cNvPr id="78" name="Ink 77">
@@ -20340,7 +20620,7 @@
               </p14:xfrm>
             </p:contentPart>
           </mc:Choice>
-          <mc:Fallback>
+          <mc:Fallback xmlns="">
             <p:pic>
               <p:nvPicPr>
                 <p:cNvPr id="78" name="Ink 77">
@@ -20371,8 +20651,8 @@
             </p:pic>
           </mc:Fallback>
         </mc:AlternateContent>
-        <mc:AlternateContent xmlns:mc="http://schemas.openxmlformats.org/markup-compatibility/2006">
-          <mc:Choice xmlns:p14="http://schemas.microsoft.com/office/powerpoint/2010/main" Requires="p14">
+        <mc:AlternateContent xmlns:mc="http://schemas.openxmlformats.org/markup-compatibility/2006" xmlns:p14="http://schemas.microsoft.com/office/powerpoint/2010/main">
+          <mc:Choice Requires="p14">
             <p:contentPart p14:bwMode="auto" r:id="rId120">
               <p14:nvContentPartPr>
                 <p14:cNvPr id="79" name="Ink 78">
@@ -20391,7 +20671,7 @@
               </p14:xfrm>
             </p:contentPart>
           </mc:Choice>
-          <mc:Fallback>
+          <mc:Fallback xmlns="">
             <p:pic>
               <p:nvPicPr>
                 <p:cNvPr id="79" name="Ink 78">
@@ -20422,8 +20702,8 @@
             </p:pic>
           </mc:Fallback>
         </mc:AlternateContent>
-        <mc:AlternateContent xmlns:mc="http://schemas.openxmlformats.org/markup-compatibility/2006">
-          <mc:Choice xmlns:p14="http://schemas.microsoft.com/office/powerpoint/2010/main" Requires="p14">
+        <mc:AlternateContent xmlns:mc="http://schemas.openxmlformats.org/markup-compatibility/2006" xmlns:p14="http://schemas.microsoft.com/office/powerpoint/2010/main">
+          <mc:Choice Requires="p14">
             <p:contentPart p14:bwMode="auto" r:id="rId122">
               <p14:nvContentPartPr>
                 <p14:cNvPr id="80" name="Ink 79">
@@ -20442,7 +20722,7 @@
               </p14:xfrm>
             </p:contentPart>
           </mc:Choice>
-          <mc:Fallback>
+          <mc:Fallback xmlns="">
             <p:pic>
               <p:nvPicPr>
                 <p:cNvPr id="80" name="Ink 79">
@@ -20473,8 +20753,8 @@
             </p:pic>
           </mc:Fallback>
         </mc:AlternateContent>
-        <mc:AlternateContent xmlns:mc="http://schemas.openxmlformats.org/markup-compatibility/2006">
-          <mc:Choice xmlns:p14="http://schemas.microsoft.com/office/powerpoint/2010/main" Requires="p14">
+        <mc:AlternateContent xmlns:mc="http://schemas.openxmlformats.org/markup-compatibility/2006" xmlns:p14="http://schemas.microsoft.com/office/powerpoint/2010/main">
+          <mc:Choice Requires="p14">
             <p:contentPart p14:bwMode="auto" r:id="rId124">
               <p14:nvContentPartPr>
                 <p14:cNvPr id="81" name="Ink 80">
@@ -20493,7 +20773,7 @@
               </p14:xfrm>
             </p:contentPart>
           </mc:Choice>
-          <mc:Fallback>
+          <mc:Fallback xmlns="">
             <p:pic>
               <p:nvPicPr>
                 <p:cNvPr id="81" name="Ink 80">
@@ -20524,8 +20804,8 @@
             </p:pic>
           </mc:Fallback>
         </mc:AlternateContent>
-        <mc:AlternateContent xmlns:mc="http://schemas.openxmlformats.org/markup-compatibility/2006">
-          <mc:Choice xmlns:p14="http://schemas.microsoft.com/office/powerpoint/2010/main" Requires="p14">
+        <mc:AlternateContent xmlns:mc="http://schemas.openxmlformats.org/markup-compatibility/2006" xmlns:p14="http://schemas.microsoft.com/office/powerpoint/2010/main">
+          <mc:Choice Requires="p14">
             <p:contentPart p14:bwMode="auto" r:id="rId126">
               <p14:nvContentPartPr>
                 <p14:cNvPr id="84" name="Ink 83">
@@ -20544,7 +20824,7 @@
               </p14:xfrm>
             </p:contentPart>
           </mc:Choice>
-          <mc:Fallback>
+          <mc:Fallback xmlns="">
             <p:pic>
               <p:nvPicPr>
                 <p:cNvPr id="84" name="Ink 83">
@@ -20575,8 +20855,8 @@
             </p:pic>
           </mc:Fallback>
         </mc:AlternateContent>
-        <mc:AlternateContent xmlns:mc="http://schemas.openxmlformats.org/markup-compatibility/2006">
-          <mc:Choice xmlns:p14="http://schemas.microsoft.com/office/powerpoint/2010/main" Requires="p14">
+        <mc:AlternateContent xmlns:mc="http://schemas.openxmlformats.org/markup-compatibility/2006" xmlns:p14="http://schemas.microsoft.com/office/powerpoint/2010/main">
+          <mc:Choice Requires="p14">
             <p:contentPart p14:bwMode="auto" r:id="rId128">
               <p14:nvContentPartPr>
                 <p14:cNvPr id="85" name="Ink 84">
@@ -20595,7 +20875,7 @@
               </p14:xfrm>
             </p:contentPart>
           </mc:Choice>
-          <mc:Fallback>
+          <mc:Fallback xmlns="">
             <p:pic>
               <p:nvPicPr>
                 <p:cNvPr id="85" name="Ink 84">
@@ -20647,8 +20927,8 @@
             <a:chExt cx="887400" cy="490320"/>
           </a:xfrm>
         </p:grpSpPr>
-        <mc:AlternateContent xmlns:mc="http://schemas.openxmlformats.org/markup-compatibility/2006">
-          <mc:Choice xmlns:p14="http://schemas.microsoft.com/office/powerpoint/2010/main" Requires="p14">
+        <mc:AlternateContent xmlns:mc="http://schemas.openxmlformats.org/markup-compatibility/2006" xmlns:p14="http://schemas.microsoft.com/office/powerpoint/2010/main">
+          <mc:Choice Requires="p14">
             <p:contentPart p14:bwMode="auto" r:id="rId130">
               <p14:nvContentPartPr>
                 <p14:cNvPr id="87" name="Ink 86">
@@ -20667,7 +20947,7 @@
               </p14:xfrm>
             </p:contentPart>
           </mc:Choice>
-          <mc:Fallback>
+          <mc:Fallback xmlns="">
             <p:pic>
               <p:nvPicPr>
                 <p:cNvPr id="87" name="Ink 86">
@@ -20698,8 +20978,8 @@
             </p:pic>
           </mc:Fallback>
         </mc:AlternateContent>
-        <mc:AlternateContent xmlns:mc="http://schemas.openxmlformats.org/markup-compatibility/2006">
-          <mc:Choice xmlns:p14="http://schemas.microsoft.com/office/powerpoint/2010/main" Requires="p14">
+        <mc:AlternateContent xmlns:mc="http://schemas.openxmlformats.org/markup-compatibility/2006" xmlns:p14="http://schemas.microsoft.com/office/powerpoint/2010/main">
+          <mc:Choice Requires="p14">
             <p:contentPart p14:bwMode="auto" r:id="rId132">
               <p14:nvContentPartPr>
                 <p14:cNvPr id="88" name="Ink 87">
@@ -20718,7 +20998,7 @@
               </p14:xfrm>
             </p:contentPart>
           </mc:Choice>
-          <mc:Fallback>
+          <mc:Fallback xmlns="">
             <p:pic>
               <p:nvPicPr>
                 <p:cNvPr id="88" name="Ink 87">
@@ -20770,8 +21050,8 @@
             <a:chExt cx="477720" cy="395280"/>
           </a:xfrm>
         </p:grpSpPr>
-        <mc:AlternateContent xmlns:mc="http://schemas.openxmlformats.org/markup-compatibility/2006">
-          <mc:Choice xmlns:p14="http://schemas.microsoft.com/office/powerpoint/2010/main" Requires="p14">
+        <mc:AlternateContent xmlns:mc="http://schemas.openxmlformats.org/markup-compatibility/2006" xmlns:p14="http://schemas.microsoft.com/office/powerpoint/2010/main">
+          <mc:Choice Requires="p14">
             <p:contentPart p14:bwMode="auto" r:id="rId134">
               <p14:nvContentPartPr>
                 <p14:cNvPr id="90" name="Ink 89">
@@ -20790,7 +21070,7 @@
               </p14:xfrm>
             </p:contentPart>
           </mc:Choice>
-          <mc:Fallback>
+          <mc:Fallback xmlns="">
             <p:pic>
               <p:nvPicPr>
                 <p:cNvPr id="90" name="Ink 89">
@@ -20821,8 +21101,8 @@
             </p:pic>
           </mc:Fallback>
         </mc:AlternateContent>
-        <mc:AlternateContent xmlns:mc="http://schemas.openxmlformats.org/markup-compatibility/2006">
-          <mc:Choice xmlns:p14="http://schemas.microsoft.com/office/powerpoint/2010/main" Requires="p14">
+        <mc:AlternateContent xmlns:mc="http://schemas.openxmlformats.org/markup-compatibility/2006" xmlns:p14="http://schemas.microsoft.com/office/powerpoint/2010/main">
+          <mc:Choice Requires="p14">
             <p:contentPart p14:bwMode="auto" r:id="rId136">
               <p14:nvContentPartPr>
                 <p14:cNvPr id="91" name="Ink 90">
@@ -20841,7 +21121,7 @@
               </p14:xfrm>
             </p:contentPart>
           </mc:Choice>
-          <mc:Fallback>
+          <mc:Fallback xmlns="">
             <p:pic>
               <p:nvPicPr>
                 <p:cNvPr id="91" name="Ink 90">
@@ -20872,8 +21152,8 @@
             </p:pic>
           </mc:Fallback>
         </mc:AlternateContent>
-        <mc:AlternateContent xmlns:mc="http://schemas.openxmlformats.org/markup-compatibility/2006">
-          <mc:Choice xmlns:p14="http://schemas.microsoft.com/office/powerpoint/2010/main" Requires="p14">
+        <mc:AlternateContent xmlns:mc="http://schemas.openxmlformats.org/markup-compatibility/2006" xmlns:p14="http://schemas.microsoft.com/office/powerpoint/2010/main">
+          <mc:Choice Requires="p14">
             <p:contentPart p14:bwMode="auto" r:id="rId138">
               <p14:nvContentPartPr>
                 <p14:cNvPr id="92" name="Ink 91">
@@ -20892,7 +21172,7 @@
               </p14:xfrm>
             </p:contentPart>
           </mc:Choice>
-          <mc:Fallback>
+          <mc:Fallback xmlns="">
             <p:pic>
               <p:nvPicPr>
                 <p:cNvPr id="92" name="Ink 91">
@@ -20924,8 +21204,8 @@
           </mc:Fallback>
         </mc:AlternateContent>
       </p:grpSp>
-      <mc:AlternateContent xmlns:mc="http://schemas.openxmlformats.org/markup-compatibility/2006">
-        <mc:Choice xmlns:p14="http://schemas.microsoft.com/office/powerpoint/2010/main" Requires="p14">
+      <mc:AlternateContent xmlns:mc="http://schemas.openxmlformats.org/markup-compatibility/2006" xmlns:p14="http://schemas.microsoft.com/office/powerpoint/2010/main">
+        <mc:Choice Requires="p14">
           <p:contentPart p14:bwMode="auto" r:id="rId140">
             <p14:nvContentPartPr>
               <p14:cNvPr id="101" name="Ink 100">
@@ -20944,7 +21224,7 @@
             </p14:xfrm>
           </p:contentPart>
         </mc:Choice>
-        <mc:Fallback>
+        <mc:Fallback xmlns="">
           <p:pic>
             <p:nvPicPr>
               <p:cNvPr id="101" name="Ink 100">
@@ -20975,8 +21255,8 @@
           </p:pic>
         </mc:Fallback>
       </mc:AlternateContent>
-      <mc:AlternateContent xmlns:mc="http://schemas.openxmlformats.org/markup-compatibility/2006">
-        <mc:Choice xmlns:p14="http://schemas.microsoft.com/office/powerpoint/2010/main" Requires="p14">
+      <mc:AlternateContent xmlns:mc="http://schemas.openxmlformats.org/markup-compatibility/2006" xmlns:p14="http://schemas.microsoft.com/office/powerpoint/2010/main">
+        <mc:Choice Requires="p14">
           <p:contentPart p14:bwMode="auto" r:id="rId142">
             <p14:nvContentPartPr>
               <p14:cNvPr id="102" name="Ink 101">
@@ -20995,7 +21275,7 @@
             </p14:xfrm>
           </p:contentPart>
         </mc:Choice>
-        <mc:Fallback>
+        <mc:Fallback xmlns="">
           <p:pic>
             <p:nvPicPr>
               <p:cNvPr id="102" name="Ink 101">
@@ -21026,8 +21306,8 @@
           </p:pic>
         </mc:Fallback>
       </mc:AlternateContent>
-      <mc:AlternateContent xmlns:mc="http://schemas.openxmlformats.org/markup-compatibility/2006">
-        <mc:Choice xmlns:p14="http://schemas.microsoft.com/office/powerpoint/2010/main" Requires="p14">
+      <mc:AlternateContent xmlns:mc="http://schemas.openxmlformats.org/markup-compatibility/2006" xmlns:p14="http://schemas.microsoft.com/office/powerpoint/2010/main">
+        <mc:Choice Requires="p14">
           <p:contentPart p14:bwMode="auto" r:id="rId144">
             <p14:nvContentPartPr>
               <p14:cNvPr id="103" name="Ink 102">
@@ -21046,7 +21326,7 @@
             </p14:xfrm>
           </p:contentPart>
         </mc:Choice>
-        <mc:Fallback>
+        <mc:Fallback xmlns="">
           <p:pic>
             <p:nvPicPr>
               <p:cNvPr id="103" name="Ink 102">
@@ -21077,8 +21357,8 @@
           </p:pic>
         </mc:Fallback>
       </mc:AlternateContent>
-      <mc:AlternateContent xmlns:mc="http://schemas.openxmlformats.org/markup-compatibility/2006">
-        <mc:Choice xmlns:p14="http://schemas.microsoft.com/office/powerpoint/2010/main" Requires="p14">
+      <mc:AlternateContent xmlns:mc="http://schemas.openxmlformats.org/markup-compatibility/2006" xmlns:p14="http://schemas.microsoft.com/office/powerpoint/2010/main">
+        <mc:Choice Requires="p14">
           <p:contentPart p14:bwMode="auto" r:id="rId146">
             <p14:nvContentPartPr>
               <p14:cNvPr id="105" name="Ink 104">
@@ -21097,7 +21377,7 @@
             </p14:xfrm>
           </p:contentPart>
         </mc:Choice>
-        <mc:Fallback>
+        <mc:Fallback xmlns="">
           <p:pic>
             <p:nvPicPr>
               <p:cNvPr id="105" name="Ink 104">
@@ -21128,8 +21408,8 @@
           </p:pic>
         </mc:Fallback>
       </mc:AlternateContent>
-      <mc:AlternateContent xmlns:mc="http://schemas.openxmlformats.org/markup-compatibility/2006">
-        <mc:Choice xmlns:p14="http://schemas.microsoft.com/office/powerpoint/2010/main" Requires="p14">
+      <mc:AlternateContent xmlns:mc="http://schemas.openxmlformats.org/markup-compatibility/2006" xmlns:p14="http://schemas.microsoft.com/office/powerpoint/2010/main">
+        <mc:Choice Requires="p14">
           <p:contentPart p14:bwMode="auto" r:id="rId148">
             <p14:nvContentPartPr>
               <p14:cNvPr id="106" name="Ink 105">
@@ -21148,7 +21428,7 @@
             </p14:xfrm>
           </p:contentPart>
         </mc:Choice>
-        <mc:Fallback>
+        <mc:Fallback xmlns="">
           <p:pic>
             <p:nvPicPr>
               <p:cNvPr id="106" name="Ink 105">
@@ -21179,8 +21459,8 @@
           </p:pic>
         </mc:Fallback>
       </mc:AlternateContent>
-      <mc:AlternateContent xmlns:mc="http://schemas.openxmlformats.org/markup-compatibility/2006">
-        <mc:Choice xmlns:p14="http://schemas.microsoft.com/office/powerpoint/2010/main" Requires="p14">
+      <mc:AlternateContent xmlns:mc="http://schemas.openxmlformats.org/markup-compatibility/2006" xmlns:p14="http://schemas.microsoft.com/office/powerpoint/2010/main">
+        <mc:Choice Requires="p14">
           <p:contentPart p14:bwMode="auto" r:id="rId150">
             <p14:nvContentPartPr>
               <p14:cNvPr id="115" name="Ink 114">
@@ -21199,7 +21479,7 @@
             </p14:xfrm>
           </p:contentPart>
         </mc:Choice>
-        <mc:Fallback>
+        <mc:Fallback xmlns="">
           <p:pic>
             <p:nvPicPr>
               <p:cNvPr id="115" name="Ink 114">
@@ -21250,8 +21530,8 @@
             <a:chExt cx="1004760" cy="492840"/>
           </a:xfrm>
         </p:grpSpPr>
-        <mc:AlternateContent xmlns:mc="http://schemas.openxmlformats.org/markup-compatibility/2006">
-          <mc:Choice xmlns:p14="http://schemas.microsoft.com/office/powerpoint/2010/main" Requires="p14">
+        <mc:AlternateContent xmlns:mc="http://schemas.openxmlformats.org/markup-compatibility/2006" xmlns:p14="http://schemas.microsoft.com/office/powerpoint/2010/main">
+          <mc:Choice Requires="p14">
             <p:contentPart p14:bwMode="auto" r:id="rId152">
               <p14:nvContentPartPr>
                 <p14:cNvPr id="94" name="Ink 93">
@@ -21270,7 +21550,7 @@
               </p14:xfrm>
             </p:contentPart>
           </mc:Choice>
-          <mc:Fallback>
+          <mc:Fallback xmlns="">
             <p:pic>
               <p:nvPicPr>
                 <p:cNvPr id="94" name="Ink 93">
@@ -21301,8 +21581,8 @@
             </p:pic>
           </mc:Fallback>
         </mc:AlternateContent>
-        <mc:AlternateContent xmlns:mc="http://schemas.openxmlformats.org/markup-compatibility/2006">
-          <mc:Choice xmlns:p14="http://schemas.microsoft.com/office/powerpoint/2010/main" Requires="p14">
+        <mc:AlternateContent xmlns:mc="http://schemas.openxmlformats.org/markup-compatibility/2006" xmlns:p14="http://schemas.microsoft.com/office/powerpoint/2010/main">
+          <mc:Choice Requires="p14">
             <p:contentPart p14:bwMode="auto" r:id="rId154">
               <p14:nvContentPartPr>
                 <p14:cNvPr id="95" name="Ink 94">
@@ -21321,7 +21601,7 @@
               </p14:xfrm>
             </p:contentPart>
           </mc:Choice>
-          <mc:Fallback>
+          <mc:Fallback xmlns="">
             <p:pic>
               <p:nvPicPr>
                 <p:cNvPr id="95" name="Ink 94">
@@ -21352,8 +21632,8 @@
             </p:pic>
           </mc:Fallback>
         </mc:AlternateContent>
-        <mc:AlternateContent xmlns:mc="http://schemas.openxmlformats.org/markup-compatibility/2006">
-          <mc:Choice xmlns:p14="http://schemas.microsoft.com/office/powerpoint/2010/main" Requires="p14">
+        <mc:AlternateContent xmlns:mc="http://schemas.openxmlformats.org/markup-compatibility/2006" xmlns:p14="http://schemas.microsoft.com/office/powerpoint/2010/main">
+          <mc:Choice Requires="p14">
             <p:contentPart p14:bwMode="auto" r:id="rId156">
               <p14:nvContentPartPr>
                 <p14:cNvPr id="96" name="Ink 95">
@@ -21372,7 +21652,7 @@
               </p14:xfrm>
             </p:contentPart>
           </mc:Choice>
-          <mc:Fallback>
+          <mc:Fallback xmlns="">
             <p:pic>
               <p:nvPicPr>
                 <p:cNvPr id="96" name="Ink 95">
@@ -21403,8 +21683,8 @@
             </p:pic>
           </mc:Fallback>
         </mc:AlternateContent>
-        <mc:AlternateContent xmlns:mc="http://schemas.openxmlformats.org/markup-compatibility/2006">
-          <mc:Choice xmlns:p14="http://schemas.microsoft.com/office/powerpoint/2010/main" Requires="p14">
+        <mc:AlternateContent xmlns:mc="http://schemas.openxmlformats.org/markup-compatibility/2006" xmlns:p14="http://schemas.microsoft.com/office/powerpoint/2010/main">
+          <mc:Choice Requires="p14">
             <p:contentPart p14:bwMode="auto" r:id="rId158">
               <p14:nvContentPartPr>
                 <p14:cNvPr id="97" name="Ink 96">
@@ -21423,7 +21703,7 @@
               </p14:xfrm>
             </p:contentPart>
           </mc:Choice>
-          <mc:Fallback>
+          <mc:Fallback xmlns="">
             <p:pic>
               <p:nvPicPr>
                 <p:cNvPr id="97" name="Ink 96">
@@ -21454,8 +21734,8 @@
             </p:pic>
           </mc:Fallback>
         </mc:AlternateContent>
-        <mc:AlternateContent xmlns:mc="http://schemas.openxmlformats.org/markup-compatibility/2006">
-          <mc:Choice xmlns:p14="http://schemas.microsoft.com/office/powerpoint/2010/main" Requires="p14">
+        <mc:AlternateContent xmlns:mc="http://schemas.openxmlformats.org/markup-compatibility/2006" xmlns:p14="http://schemas.microsoft.com/office/powerpoint/2010/main">
+          <mc:Choice Requires="p14">
             <p:contentPart p14:bwMode="auto" r:id="rId160">
               <p14:nvContentPartPr>
                 <p14:cNvPr id="98" name="Ink 97">
@@ -21474,7 +21754,7 @@
               </p14:xfrm>
             </p:contentPart>
           </mc:Choice>
-          <mc:Fallback>
+          <mc:Fallback xmlns="">
             <p:pic>
               <p:nvPicPr>
                 <p:cNvPr id="98" name="Ink 97">
@@ -21505,8 +21785,8 @@
             </p:pic>
           </mc:Fallback>
         </mc:AlternateContent>
-        <mc:AlternateContent xmlns:mc="http://schemas.openxmlformats.org/markup-compatibility/2006">
-          <mc:Choice xmlns:p14="http://schemas.microsoft.com/office/powerpoint/2010/main" Requires="p14">
+        <mc:AlternateContent xmlns:mc="http://schemas.openxmlformats.org/markup-compatibility/2006" xmlns:p14="http://schemas.microsoft.com/office/powerpoint/2010/main">
+          <mc:Choice Requires="p14">
             <p:contentPart p14:bwMode="auto" r:id="rId162">
               <p14:nvContentPartPr>
                 <p14:cNvPr id="99" name="Ink 98">
@@ -21525,7 +21805,7 @@
               </p14:xfrm>
             </p:contentPart>
           </mc:Choice>
-          <mc:Fallback>
+          <mc:Fallback xmlns="">
             <p:pic>
               <p:nvPicPr>
                 <p:cNvPr id="99" name="Ink 98">
@@ -21556,8 +21836,8 @@
             </p:pic>
           </mc:Fallback>
         </mc:AlternateContent>
-        <mc:AlternateContent xmlns:mc="http://schemas.openxmlformats.org/markup-compatibility/2006">
-          <mc:Choice xmlns:p14="http://schemas.microsoft.com/office/powerpoint/2010/main" Requires="p14">
+        <mc:AlternateContent xmlns:mc="http://schemas.openxmlformats.org/markup-compatibility/2006" xmlns:p14="http://schemas.microsoft.com/office/powerpoint/2010/main">
+          <mc:Choice Requires="p14">
             <p:contentPart p14:bwMode="auto" r:id="rId164">
               <p14:nvContentPartPr>
                 <p14:cNvPr id="116" name="Ink 115">
@@ -21576,7 +21856,7 @@
               </p14:xfrm>
             </p:contentPart>
           </mc:Choice>
-          <mc:Fallback>
+          <mc:Fallback xmlns="">
             <p:pic>
               <p:nvPicPr>
                 <p:cNvPr id="116" name="Ink 115">
@@ -21607,8 +21887,8 @@
             </p:pic>
           </mc:Fallback>
         </mc:AlternateContent>
-        <mc:AlternateContent xmlns:mc="http://schemas.openxmlformats.org/markup-compatibility/2006">
-          <mc:Choice xmlns:p14="http://schemas.microsoft.com/office/powerpoint/2010/main" Requires="p14">
+        <mc:AlternateContent xmlns:mc="http://schemas.openxmlformats.org/markup-compatibility/2006" xmlns:p14="http://schemas.microsoft.com/office/powerpoint/2010/main">
+          <mc:Choice Requires="p14">
             <p:contentPart p14:bwMode="auto" r:id="rId166">
               <p14:nvContentPartPr>
                 <p14:cNvPr id="117" name="Ink 116">
@@ -21627,7 +21907,7 @@
               </p14:xfrm>
             </p:contentPart>
           </mc:Choice>
-          <mc:Fallback>
+          <mc:Fallback xmlns="">
             <p:pic>
               <p:nvPicPr>
                 <p:cNvPr id="117" name="Ink 116">
@@ -21658,8 +21938,8 @@
             </p:pic>
           </mc:Fallback>
         </mc:AlternateContent>
-        <mc:AlternateContent xmlns:mc="http://schemas.openxmlformats.org/markup-compatibility/2006">
-          <mc:Choice xmlns:p14="http://schemas.microsoft.com/office/powerpoint/2010/main" Requires="p14">
+        <mc:AlternateContent xmlns:mc="http://schemas.openxmlformats.org/markup-compatibility/2006" xmlns:p14="http://schemas.microsoft.com/office/powerpoint/2010/main">
+          <mc:Choice Requires="p14">
             <p:contentPart p14:bwMode="auto" r:id="rId168">
               <p14:nvContentPartPr>
                 <p14:cNvPr id="118" name="Ink 117">
@@ -21678,7 +21958,7 @@
               </p14:xfrm>
             </p:contentPart>
           </mc:Choice>
-          <mc:Fallback>
+          <mc:Fallback xmlns="">
             <p:pic>
               <p:nvPicPr>
                 <p:cNvPr id="118" name="Ink 117">
@@ -21710,8 +21990,8 @@
           </mc:Fallback>
         </mc:AlternateContent>
       </p:grpSp>
-      <mc:AlternateContent xmlns:mc="http://schemas.openxmlformats.org/markup-compatibility/2006">
-        <mc:Choice xmlns:p14="http://schemas.microsoft.com/office/powerpoint/2010/main" Requires="p14">
+      <mc:AlternateContent xmlns:mc="http://schemas.openxmlformats.org/markup-compatibility/2006" xmlns:p14="http://schemas.microsoft.com/office/powerpoint/2010/main">
+        <mc:Choice Requires="p14">
           <p:contentPart p14:bwMode="auto" r:id="rId170">
             <p14:nvContentPartPr>
               <p14:cNvPr id="120" name="Ink 119">
@@ -21730,7 +22010,7 @@
             </p14:xfrm>
           </p:contentPart>
         </mc:Choice>
-        <mc:Fallback>
+        <mc:Fallback xmlns="">
           <p:pic>
             <p:nvPicPr>
               <p:cNvPr id="120" name="Ink 119">
@@ -21761,8 +22041,8 @@
           </p:pic>
         </mc:Fallback>
       </mc:AlternateContent>
-      <mc:AlternateContent xmlns:mc="http://schemas.openxmlformats.org/markup-compatibility/2006">
-        <mc:Choice xmlns:p14="http://schemas.microsoft.com/office/powerpoint/2010/main" Requires="p14">
+      <mc:AlternateContent xmlns:mc="http://schemas.openxmlformats.org/markup-compatibility/2006" xmlns:p14="http://schemas.microsoft.com/office/powerpoint/2010/main">
+        <mc:Choice Requires="p14">
           <p:contentPart p14:bwMode="auto" r:id="rId172">
             <p14:nvContentPartPr>
               <p14:cNvPr id="122" name="Ink 121">
@@ -21781,7 +22061,7 @@
             </p14:xfrm>
           </p:contentPart>
         </mc:Choice>
-        <mc:Fallback>
+        <mc:Fallback xmlns="">
           <p:pic>
             <p:nvPicPr>
               <p:cNvPr id="122" name="Ink 121">
@@ -21988,6 +22268,1054 @@
           </a:prstGeom>
         </p:spPr>
       </p:pic>
+      <p:pic>
+        <p:nvPicPr>
+          <p:cNvPr id="4" name="Picture 3" descr="A green tick on a black background&#10;&#10;AI-generated content may be incorrect.">
+            <a:extLst>
+              <a:ext uri="{FF2B5EF4-FFF2-40B4-BE49-F238E27FC236}">
+                <a16:creationId xmlns:a16="http://schemas.microsoft.com/office/drawing/2014/main" id="{55F60937-32F1-0402-F717-300967C3E07B}"/>
+              </a:ext>
+            </a:extLst>
+          </p:cNvPr>
+          <p:cNvPicPr>
+            <a:picLocks noChangeAspect="1"/>
+          </p:cNvPicPr>
+          <p:nvPr/>
+        </p:nvPicPr>
+        <p:blipFill>
+          <a:blip r:embed="rId174" cstate="print">
+            <a:extLst>
+              <a:ext uri="{28A0092B-C50C-407E-A947-70E740481C1C}">
+                <a14:useLocalDpi xmlns:a14="http://schemas.microsoft.com/office/drawing/2010/main" val="0"/>
+              </a:ext>
+              <a:ext uri="{837473B0-CC2E-450A-ABE3-18F120FF3D39}">
+                <a1611:picAttrSrcUrl xmlns:a1611="http://schemas.microsoft.com/office/drawing/2016/11/main" r:id="rId175"/>
+              </a:ext>
+            </a:extLst>
+          </a:blip>
+          <a:stretch>
+            <a:fillRect/>
+          </a:stretch>
+        </p:blipFill>
+        <p:spPr>
+          <a:xfrm>
+            <a:off x="6030177" y="3495342"/>
+            <a:ext cx="309062" cy="254976"/>
+          </a:xfrm>
+          <a:prstGeom prst="rect">
+            <a:avLst/>
+          </a:prstGeom>
+        </p:spPr>
+      </p:pic>
+      <p:pic>
+        <p:nvPicPr>
+          <p:cNvPr id="5" name="Picture 4" descr="A green tick on a black background&#10;&#10;AI-generated content may be incorrect.">
+            <a:extLst>
+              <a:ext uri="{FF2B5EF4-FFF2-40B4-BE49-F238E27FC236}">
+                <a16:creationId xmlns:a16="http://schemas.microsoft.com/office/drawing/2014/main" id="{05E38C7A-FB95-D078-2AF1-1C52884A6043}"/>
+              </a:ext>
+            </a:extLst>
+          </p:cNvPr>
+          <p:cNvPicPr>
+            <a:picLocks noChangeAspect="1"/>
+          </p:cNvPicPr>
+          <p:nvPr/>
+        </p:nvPicPr>
+        <p:blipFill>
+          <a:blip r:embed="rId174" cstate="print">
+            <a:extLst>
+              <a:ext uri="{28A0092B-C50C-407E-A947-70E740481C1C}">
+                <a14:useLocalDpi xmlns:a14="http://schemas.microsoft.com/office/drawing/2010/main" val="0"/>
+              </a:ext>
+              <a:ext uri="{837473B0-CC2E-450A-ABE3-18F120FF3D39}">
+                <a1611:picAttrSrcUrl xmlns:a1611="http://schemas.microsoft.com/office/drawing/2016/11/main" r:id="rId175"/>
+              </a:ext>
+            </a:extLst>
+          </a:blip>
+          <a:stretch>
+            <a:fillRect/>
+          </a:stretch>
+        </p:blipFill>
+        <p:spPr>
+          <a:xfrm>
+            <a:off x="5918670" y="2824698"/>
+            <a:ext cx="309062" cy="254976"/>
+          </a:xfrm>
+          <a:prstGeom prst="rect">
+            <a:avLst/>
+          </a:prstGeom>
+        </p:spPr>
+      </p:pic>
+      <p:pic>
+        <p:nvPicPr>
+          <p:cNvPr id="6" name="Picture 5" descr="A green tick on a black background&#10;&#10;AI-generated content may be incorrect.">
+            <a:extLst>
+              <a:ext uri="{FF2B5EF4-FFF2-40B4-BE49-F238E27FC236}">
+                <a16:creationId xmlns:a16="http://schemas.microsoft.com/office/drawing/2014/main" id="{156B1660-04A6-23C2-14A4-9473431F4D8C}"/>
+              </a:ext>
+            </a:extLst>
+          </p:cNvPr>
+          <p:cNvPicPr>
+            <a:picLocks noChangeAspect="1"/>
+          </p:cNvPicPr>
+          <p:nvPr/>
+        </p:nvPicPr>
+        <p:blipFill>
+          <a:blip r:embed="rId174" cstate="print">
+            <a:extLst>
+              <a:ext uri="{28A0092B-C50C-407E-A947-70E740481C1C}">
+                <a14:useLocalDpi xmlns:a14="http://schemas.microsoft.com/office/drawing/2010/main" val="0"/>
+              </a:ext>
+              <a:ext uri="{837473B0-CC2E-450A-ABE3-18F120FF3D39}">
+                <a1611:picAttrSrcUrl xmlns:a1611="http://schemas.microsoft.com/office/drawing/2016/11/main" r:id="rId175"/>
+              </a:ext>
+            </a:extLst>
+          </a:blip>
+          <a:stretch>
+            <a:fillRect/>
+          </a:stretch>
+        </p:blipFill>
+        <p:spPr>
+          <a:xfrm>
+            <a:off x="1328066" y="1992294"/>
+            <a:ext cx="309062" cy="254976"/>
+          </a:xfrm>
+          <a:prstGeom prst="rect">
+            <a:avLst/>
+          </a:prstGeom>
+        </p:spPr>
+      </p:pic>
+      <p:pic>
+        <p:nvPicPr>
+          <p:cNvPr id="7" name="Picture 6" descr="A green tick on a black background&#10;&#10;AI-generated content may be incorrect.">
+            <a:extLst>
+              <a:ext uri="{FF2B5EF4-FFF2-40B4-BE49-F238E27FC236}">
+                <a16:creationId xmlns:a16="http://schemas.microsoft.com/office/drawing/2014/main" id="{559CBAE1-4D5B-326B-EEE9-3B22EE40E305}"/>
+              </a:ext>
+            </a:extLst>
+          </p:cNvPr>
+          <p:cNvPicPr>
+            <a:picLocks noChangeAspect="1"/>
+          </p:cNvPicPr>
+          <p:nvPr/>
+        </p:nvPicPr>
+        <p:blipFill>
+          <a:blip r:embed="rId174" cstate="print">
+            <a:extLst>
+              <a:ext uri="{28A0092B-C50C-407E-A947-70E740481C1C}">
+                <a14:useLocalDpi xmlns:a14="http://schemas.microsoft.com/office/drawing/2010/main" val="0"/>
+              </a:ext>
+              <a:ext uri="{837473B0-CC2E-450A-ABE3-18F120FF3D39}">
+                <a1611:picAttrSrcUrl xmlns:a1611="http://schemas.microsoft.com/office/drawing/2016/11/main" r:id="rId175"/>
+              </a:ext>
+            </a:extLst>
+          </a:blip>
+          <a:stretch>
+            <a:fillRect/>
+          </a:stretch>
+        </p:blipFill>
+        <p:spPr>
+          <a:xfrm>
+            <a:off x="6865813" y="3508791"/>
+            <a:ext cx="309062" cy="254976"/>
+          </a:xfrm>
+          <a:prstGeom prst="rect">
+            <a:avLst/>
+          </a:prstGeom>
+        </p:spPr>
+      </p:pic>
+      <p:sp>
+        <p:nvSpPr>
+          <p:cNvPr id="15" name="Rectangle 14">
+            <a:extLst>
+              <a:ext uri="{FF2B5EF4-FFF2-40B4-BE49-F238E27FC236}">
+                <a16:creationId xmlns:a16="http://schemas.microsoft.com/office/drawing/2014/main" id="{B8AC6BAD-0EA8-6BBD-5522-501510D43F7D}"/>
+              </a:ext>
+            </a:extLst>
+          </p:cNvPr>
+          <p:cNvSpPr/>
+          <p:nvPr/>
+        </p:nvSpPr>
+        <p:spPr>
+          <a:xfrm>
+            <a:off x="4164212" y="361950"/>
+            <a:ext cx="864988" cy="152400"/>
+          </a:xfrm>
+          <a:prstGeom prst="rect">
+            <a:avLst/>
+          </a:prstGeom>
+        </p:spPr>
+        <p:style>
+          <a:lnRef idx="2">
+            <a:schemeClr val="accent1">
+              <a:shade val="15000"/>
+            </a:schemeClr>
+          </a:lnRef>
+          <a:fillRef idx="1">
+            <a:schemeClr val="accent1"/>
+          </a:fillRef>
+          <a:effectRef idx="0">
+            <a:schemeClr val="accent1"/>
+          </a:effectRef>
+          <a:fontRef idx="minor">
+            <a:schemeClr val="lt1"/>
+          </a:fontRef>
+        </p:style>
+        <p:txBody>
+          <a:bodyPr rtlCol="0" anchor="ctr"/>
+          <a:lstStyle/>
+          <a:p>
+            <a:pPr algn="ctr"/>
+            <a:r>
+              <a:rPr lang="en-IN" dirty="0" err="1"/>
+              <a:t>dest</a:t>
+            </a:r>
+            <a:endParaRPr lang="en-IN" dirty="0"/>
+          </a:p>
+        </p:txBody>
+      </p:sp>
+      <p:pic>
+        <p:nvPicPr>
+          <p:cNvPr id="17" name="Picture 16" descr="A green tick on a black background&#10;&#10;AI-generated content may be incorrect.">
+            <a:extLst>
+              <a:ext uri="{FF2B5EF4-FFF2-40B4-BE49-F238E27FC236}">
+                <a16:creationId xmlns:a16="http://schemas.microsoft.com/office/drawing/2014/main" id="{EA244B13-7A47-28E5-F11F-8ED4894286F9}"/>
+              </a:ext>
+            </a:extLst>
+          </p:cNvPr>
+          <p:cNvPicPr>
+            <a:picLocks noChangeAspect="1"/>
+          </p:cNvPicPr>
+          <p:nvPr/>
+        </p:nvPicPr>
+        <p:blipFill>
+          <a:blip r:embed="rId174" cstate="print">
+            <a:extLst>
+              <a:ext uri="{28A0092B-C50C-407E-A947-70E740481C1C}">
+                <a14:useLocalDpi xmlns:a14="http://schemas.microsoft.com/office/drawing/2010/main" val="0"/>
+              </a:ext>
+              <a:ext uri="{837473B0-CC2E-450A-ABE3-18F120FF3D39}">
+                <a1611:picAttrSrcUrl xmlns:a1611="http://schemas.microsoft.com/office/drawing/2016/11/main" r:id="rId175"/>
+              </a:ext>
+            </a:extLst>
+          </a:blip>
+          <a:stretch>
+            <a:fillRect/>
+          </a:stretch>
+        </p:blipFill>
+        <p:spPr>
+          <a:xfrm>
+            <a:off x="4058819" y="257354"/>
+            <a:ext cx="309062" cy="254976"/>
+          </a:xfrm>
+          <a:prstGeom prst="rect">
+            <a:avLst/>
+          </a:prstGeom>
+        </p:spPr>
+      </p:pic>
+      <p:sp>
+        <p:nvSpPr>
+          <p:cNvPr id="57" name="Smiley Face 56">
+            <a:extLst>
+              <a:ext uri="{FF2B5EF4-FFF2-40B4-BE49-F238E27FC236}">
+                <a16:creationId xmlns:a16="http://schemas.microsoft.com/office/drawing/2014/main" id="{80405CDA-8545-23DE-0397-3D19C34AD170}"/>
+              </a:ext>
+            </a:extLst>
+          </p:cNvPr>
+          <p:cNvSpPr/>
+          <p:nvPr/>
+        </p:nvSpPr>
+        <p:spPr>
+          <a:xfrm>
+            <a:off x="2667000" y="3634302"/>
+            <a:ext cx="336572" cy="300240"/>
+          </a:xfrm>
+          <a:prstGeom prst="smileyFace">
+            <a:avLst/>
+          </a:prstGeom>
+        </p:spPr>
+        <p:style>
+          <a:lnRef idx="2">
+            <a:schemeClr val="accent1">
+              <a:shade val="15000"/>
+            </a:schemeClr>
+          </a:lnRef>
+          <a:fillRef idx="1">
+            <a:schemeClr val="accent1"/>
+          </a:fillRef>
+          <a:effectRef idx="0">
+            <a:schemeClr val="accent1"/>
+          </a:effectRef>
+          <a:fontRef idx="minor">
+            <a:schemeClr val="lt1"/>
+          </a:fontRef>
+        </p:style>
+        <p:txBody>
+          <a:bodyPr rtlCol="0" anchor="ctr"/>
+          <a:lstStyle/>
+          <a:p>
+            <a:pPr algn="ctr"/>
+            <a:endParaRPr lang="en-IN"/>
+          </a:p>
+        </p:txBody>
+      </p:sp>
+      <p:sp>
+        <p:nvSpPr>
+          <p:cNvPr id="65" name="Smiley Face 64">
+            <a:extLst>
+              <a:ext uri="{FF2B5EF4-FFF2-40B4-BE49-F238E27FC236}">
+                <a16:creationId xmlns:a16="http://schemas.microsoft.com/office/drawing/2014/main" id="{BEB0D1C8-DFC4-ECF0-AF4E-7A335A9D2A58}"/>
+              </a:ext>
+            </a:extLst>
+          </p:cNvPr>
+          <p:cNvSpPr/>
+          <p:nvPr/>
+        </p:nvSpPr>
+        <p:spPr>
+          <a:xfrm>
+            <a:off x="3082687" y="3634302"/>
+            <a:ext cx="336572" cy="300240"/>
+          </a:xfrm>
+          <a:prstGeom prst="smileyFace">
+            <a:avLst/>
+          </a:prstGeom>
+        </p:spPr>
+        <p:style>
+          <a:lnRef idx="2">
+            <a:schemeClr val="accent1">
+              <a:shade val="15000"/>
+            </a:schemeClr>
+          </a:lnRef>
+          <a:fillRef idx="1">
+            <a:schemeClr val="accent1"/>
+          </a:fillRef>
+          <a:effectRef idx="0">
+            <a:schemeClr val="accent1"/>
+          </a:effectRef>
+          <a:fontRef idx="minor">
+            <a:schemeClr val="lt1"/>
+          </a:fontRef>
+        </p:style>
+        <p:txBody>
+          <a:bodyPr rtlCol="0" anchor="ctr"/>
+          <a:lstStyle/>
+          <a:p>
+            <a:pPr algn="ctr"/>
+            <a:endParaRPr lang="en-IN"/>
+          </a:p>
+        </p:txBody>
+      </p:sp>
+      <p:sp>
+        <p:nvSpPr>
+          <p:cNvPr id="67" name="Smiley Face 66">
+            <a:extLst>
+              <a:ext uri="{FF2B5EF4-FFF2-40B4-BE49-F238E27FC236}">
+                <a16:creationId xmlns:a16="http://schemas.microsoft.com/office/drawing/2014/main" id="{47EA1D0E-9C6E-719B-0B81-7DC1C1083484}"/>
+              </a:ext>
+            </a:extLst>
+          </p:cNvPr>
+          <p:cNvSpPr/>
+          <p:nvPr/>
+        </p:nvSpPr>
+        <p:spPr>
+          <a:xfrm>
+            <a:off x="3497019" y="3634302"/>
+            <a:ext cx="336572" cy="300240"/>
+          </a:xfrm>
+          <a:prstGeom prst="smileyFace">
+            <a:avLst/>
+          </a:prstGeom>
+        </p:spPr>
+        <p:style>
+          <a:lnRef idx="2">
+            <a:schemeClr val="accent1">
+              <a:shade val="15000"/>
+            </a:schemeClr>
+          </a:lnRef>
+          <a:fillRef idx="1">
+            <a:schemeClr val="accent1"/>
+          </a:fillRef>
+          <a:effectRef idx="0">
+            <a:schemeClr val="accent1"/>
+          </a:effectRef>
+          <a:fontRef idx="minor">
+            <a:schemeClr val="lt1"/>
+          </a:fontRef>
+        </p:style>
+        <p:txBody>
+          <a:bodyPr rtlCol="0" anchor="ctr"/>
+          <a:lstStyle/>
+          <a:p>
+            <a:pPr algn="ctr"/>
+            <a:endParaRPr lang="en-IN"/>
+          </a:p>
+        </p:txBody>
+      </p:sp>
+      <p:sp>
+        <p:nvSpPr>
+          <p:cNvPr id="76" name="Rectangle 75">
+            <a:extLst>
+              <a:ext uri="{FF2B5EF4-FFF2-40B4-BE49-F238E27FC236}">
+                <a16:creationId xmlns:a16="http://schemas.microsoft.com/office/drawing/2014/main" id="{84D02334-4C14-AE97-EC9F-1578491AAFAE}"/>
+              </a:ext>
+            </a:extLst>
+          </p:cNvPr>
+          <p:cNvSpPr/>
+          <p:nvPr/>
+        </p:nvSpPr>
+        <p:spPr>
+          <a:xfrm>
+            <a:off x="2667000" y="4019550"/>
+            <a:ext cx="1371600" cy="254976"/>
+          </a:xfrm>
+          <a:prstGeom prst="rect">
+            <a:avLst/>
+          </a:prstGeom>
+        </p:spPr>
+        <p:style>
+          <a:lnRef idx="2">
+            <a:schemeClr val="accent1">
+              <a:shade val="15000"/>
+            </a:schemeClr>
+          </a:lnRef>
+          <a:fillRef idx="1">
+            <a:schemeClr val="accent1"/>
+          </a:fillRef>
+          <a:effectRef idx="0">
+            <a:schemeClr val="accent1"/>
+          </a:effectRef>
+          <a:fontRef idx="minor">
+            <a:schemeClr val="lt1"/>
+          </a:fontRef>
+        </p:style>
+        <p:txBody>
+          <a:bodyPr rtlCol="0" anchor="ctr"/>
+          <a:lstStyle/>
+          <a:p>
+            <a:pPr algn="ctr"/>
+            <a:r>
+              <a:rPr lang="en-IN" dirty="0"/>
+              <a:t>role</a:t>
+            </a:r>
+          </a:p>
+        </p:txBody>
+      </p:sp>
+      <p:pic>
+        <p:nvPicPr>
+          <p:cNvPr id="82" name="Picture 81" descr="A green tick on a black background&#10;&#10;AI-generated content may be incorrect.">
+            <a:extLst>
+              <a:ext uri="{FF2B5EF4-FFF2-40B4-BE49-F238E27FC236}">
+                <a16:creationId xmlns:a16="http://schemas.microsoft.com/office/drawing/2014/main" id="{81D0E111-32A6-964A-84B2-A3BC3C96BA17}"/>
+              </a:ext>
+            </a:extLst>
+          </p:cNvPr>
+          <p:cNvPicPr>
+            <a:picLocks noChangeAspect="1"/>
+          </p:cNvPicPr>
+          <p:nvPr/>
+        </p:nvPicPr>
+        <p:blipFill>
+          <a:blip r:embed="rId174" cstate="print">
+            <a:extLst>
+              <a:ext uri="{28A0092B-C50C-407E-A947-70E740481C1C}">
+                <a14:useLocalDpi xmlns:a14="http://schemas.microsoft.com/office/drawing/2010/main" val="0"/>
+              </a:ext>
+              <a:ext uri="{837473B0-CC2E-450A-ABE3-18F120FF3D39}">
+                <a1611:picAttrSrcUrl xmlns:a1611="http://schemas.microsoft.com/office/drawing/2016/11/main" r:id="rId175"/>
+              </a:ext>
+            </a:extLst>
+          </a:blip>
+          <a:stretch>
+            <a:fillRect/>
+          </a:stretch>
+        </p:blipFill>
+        <p:spPr>
+          <a:xfrm>
+            <a:off x="3855150" y="3962934"/>
+            <a:ext cx="309062" cy="254976"/>
+          </a:xfrm>
+          <a:prstGeom prst="rect">
+            <a:avLst/>
+          </a:prstGeom>
+        </p:spPr>
+      </p:pic>
+      <p:sp>
+        <p:nvSpPr>
+          <p:cNvPr id="100" name="Rectangle 99">
+            <a:extLst>
+              <a:ext uri="{FF2B5EF4-FFF2-40B4-BE49-F238E27FC236}">
+                <a16:creationId xmlns:a16="http://schemas.microsoft.com/office/drawing/2014/main" id="{1133DB69-3724-EEBD-B0BB-5D1DD5D9A39D}"/>
+              </a:ext>
+            </a:extLst>
+          </p:cNvPr>
+          <p:cNvSpPr/>
+          <p:nvPr/>
+        </p:nvSpPr>
+        <p:spPr>
+          <a:xfrm>
+            <a:off x="3044546" y="1747902"/>
+            <a:ext cx="152400" cy="960840"/>
+          </a:xfrm>
+          <a:prstGeom prst="rect">
+            <a:avLst/>
+          </a:prstGeom>
+        </p:spPr>
+        <p:style>
+          <a:lnRef idx="2">
+            <a:schemeClr val="accent1">
+              <a:shade val="15000"/>
+            </a:schemeClr>
+          </a:lnRef>
+          <a:fillRef idx="1">
+            <a:schemeClr val="accent1"/>
+          </a:fillRef>
+          <a:effectRef idx="0">
+            <a:schemeClr val="accent1"/>
+          </a:effectRef>
+          <a:fontRef idx="minor">
+            <a:schemeClr val="lt1"/>
+          </a:fontRef>
+        </p:style>
+        <p:txBody>
+          <a:bodyPr rtlCol="0" anchor="ctr"/>
+          <a:lstStyle/>
+          <a:p>
+            <a:pPr algn="ctr"/>
+            <a:endParaRPr lang="en-IN"/>
+          </a:p>
+        </p:txBody>
+      </p:sp>
+      <mc:AlternateContent xmlns:mc="http://schemas.openxmlformats.org/markup-compatibility/2006">
+        <mc:Choice xmlns:p14="http://schemas.microsoft.com/office/powerpoint/2010/main" Requires="p14">
+          <p:contentPart p14:bwMode="auto" r:id="rId176">
+            <p14:nvContentPartPr>
+              <p14:cNvPr id="150" name="Ink 149">
+                <a:extLst>
+                  <a:ext uri="{FF2B5EF4-FFF2-40B4-BE49-F238E27FC236}">
+                    <a16:creationId xmlns:a16="http://schemas.microsoft.com/office/drawing/2014/main" id="{44CFEF55-EF02-6736-D823-7AA83CF6B599}"/>
+                  </a:ext>
+                </a:extLst>
+              </p14:cNvPr>
+              <p14:cNvContentPartPr/>
+              <p14:nvPr/>
+            </p14:nvContentPartPr>
+            <p14:xfrm>
+              <a:off x="1750230" y="87582"/>
+              <a:ext cx="360" cy="360"/>
+            </p14:xfrm>
+          </p:contentPart>
+        </mc:Choice>
+        <mc:Fallback>
+          <p:pic>
+            <p:nvPicPr>
+              <p:cNvPr id="150" name="Ink 149">
+                <a:extLst>
+                  <a:ext uri="{FF2B5EF4-FFF2-40B4-BE49-F238E27FC236}">
+                    <a16:creationId xmlns:a16="http://schemas.microsoft.com/office/drawing/2014/main" id="{44CFEF55-EF02-6736-D823-7AA83CF6B599}"/>
+                  </a:ext>
+                </a:extLst>
+              </p:cNvPr>
+              <p:cNvPicPr/>
+              <p:nvPr/>
+            </p:nvPicPr>
+            <p:blipFill>
+              <a:blip r:embed="rId177"/>
+              <a:stretch>
+                <a:fillRect/>
+              </a:stretch>
+            </p:blipFill>
+            <p:spPr>
+              <a:xfrm>
+                <a:off x="1741590" y="78942"/>
+                <a:ext cx="18000" cy="18000"/>
+              </a:xfrm>
+              <a:prstGeom prst="rect">
+                <a:avLst/>
+              </a:prstGeom>
+            </p:spPr>
+          </p:pic>
+        </mc:Fallback>
+      </mc:AlternateContent>
+      <p:grpSp>
+        <p:nvGrpSpPr>
+          <p:cNvPr id="162" name="Group 161">
+            <a:extLst>
+              <a:ext uri="{FF2B5EF4-FFF2-40B4-BE49-F238E27FC236}">
+                <a16:creationId xmlns:a16="http://schemas.microsoft.com/office/drawing/2014/main" id="{9710FBDB-FDBA-C11F-79F4-057D2B2A9AF5}"/>
+              </a:ext>
+            </a:extLst>
+          </p:cNvPr>
+          <p:cNvGrpSpPr/>
+          <p:nvPr/>
+        </p:nvGrpSpPr>
+        <p:grpSpPr>
+          <a:xfrm>
+            <a:off x="1759230" y="1054542"/>
+            <a:ext cx="5060160" cy="2521080"/>
+            <a:chOff x="1759230" y="1054542"/>
+            <a:chExt cx="5060160" cy="2521080"/>
+          </a:xfrm>
+        </p:grpSpPr>
+        <mc:AlternateContent xmlns:mc="http://schemas.openxmlformats.org/markup-compatibility/2006">
+          <mc:Choice xmlns:p14="http://schemas.microsoft.com/office/powerpoint/2010/main" Requires="p14">
+            <p:contentPart p14:bwMode="auto" r:id="rId178">
+              <p14:nvContentPartPr>
+                <p14:cNvPr id="151" name="Ink 150">
+                  <a:extLst>
+                    <a:ext uri="{FF2B5EF4-FFF2-40B4-BE49-F238E27FC236}">
+                      <a16:creationId xmlns:a16="http://schemas.microsoft.com/office/drawing/2014/main" id="{A3531B26-4476-051B-6A78-8B043702D4B8}"/>
+                    </a:ext>
+                  </a:extLst>
+                </p14:cNvPr>
+                <p14:cNvContentPartPr/>
+                <p14:nvPr/>
+              </p14:nvContentPartPr>
+              <p14:xfrm>
+                <a:off x="1774710" y="2724582"/>
+                <a:ext cx="271800" cy="114840"/>
+              </p14:xfrm>
+            </p:contentPart>
+          </mc:Choice>
+          <mc:Fallback>
+            <p:pic>
+              <p:nvPicPr>
+                <p:cNvPr id="151" name="Ink 150">
+                  <a:extLst>
+                    <a:ext uri="{FF2B5EF4-FFF2-40B4-BE49-F238E27FC236}">
+                      <a16:creationId xmlns:a16="http://schemas.microsoft.com/office/drawing/2014/main" id="{A3531B26-4476-051B-6A78-8B043702D4B8}"/>
+                    </a:ext>
+                  </a:extLst>
+                </p:cNvPr>
+                <p:cNvPicPr/>
+                <p:nvPr/>
+              </p:nvPicPr>
+              <p:blipFill>
+                <a:blip r:embed="rId179"/>
+                <a:stretch>
+                  <a:fillRect/>
+                </a:stretch>
+              </p:blipFill>
+              <p:spPr>
+                <a:xfrm>
+                  <a:off x="1765710" y="2715582"/>
+                  <a:ext cx="289440" cy="132480"/>
+                </a:xfrm>
+                <a:prstGeom prst="rect">
+                  <a:avLst/>
+                </a:prstGeom>
+              </p:spPr>
+            </p:pic>
+          </mc:Fallback>
+        </mc:AlternateContent>
+        <mc:AlternateContent xmlns:mc="http://schemas.openxmlformats.org/markup-compatibility/2006">
+          <mc:Choice xmlns:p14="http://schemas.microsoft.com/office/powerpoint/2010/main" Requires="p14">
+            <p:contentPart p14:bwMode="auto" r:id="rId180">
+              <p14:nvContentPartPr>
+                <p14:cNvPr id="152" name="Ink 151">
+                  <a:extLst>
+                    <a:ext uri="{FF2B5EF4-FFF2-40B4-BE49-F238E27FC236}">
+                      <a16:creationId xmlns:a16="http://schemas.microsoft.com/office/drawing/2014/main" id="{25870221-CCA8-EE1D-EE79-78972D95673E}"/>
+                    </a:ext>
+                  </a:extLst>
+                </p14:cNvPr>
+                <p14:cNvContentPartPr/>
+                <p14:nvPr/>
+              </p14:nvContentPartPr>
+              <p14:xfrm>
+                <a:off x="1759230" y="2826102"/>
+                <a:ext cx="214920" cy="117720"/>
+              </p14:xfrm>
+            </p:contentPart>
+          </mc:Choice>
+          <mc:Fallback>
+            <p:pic>
+              <p:nvPicPr>
+                <p:cNvPr id="152" name="Ink 151">
+                  <a:extLst>
+                    <a:ext uri="{FF2B5EF4-FFF2-40B4-BE49-F238E27FC236}">
+                      <a16:creationId xmlns:a16="http://schemas.microsoft.com/office/drawing/2014/main" id="{25870221-CCA8-EE1D-EE79-78972D95673E}"/>
+                    </a:ext>
+                  </a:extLst>
+                </p:cNvPr>
+                <p:cNvPicPr/>
+                <p:nvPr/>
+              </p:nvPicPr>
+              <p:blipFill>
+                <a:blip r:embed="rId181"/>
+                <a:stretch>
+                  <a:fillRect/>
+                </a:stretch>
+              </p:blipFill>
+              <p:spPr>
+                <a:xfrm>
+                  <a:off x="1750230" y="2817462"/>
+                  <a:ext cx="232560" cy="135360"/>
+                </a:xfrm>
+                <a:prstGeom prst="rect">
+                  <a:avLst/>
+                </a:prstGeom>
+              </p:spPr>
+            </p:pic>
+          </mc:Fallback>
+        </mc:AlternateContent>
+        <mc:AlternateContent xmlns:mc="http://schemas.openxmlformats.org/markup-compatibility/2006">
+          <mc:Choice xmlns:p14="http://schemas.microsoft.com/office/powerpoint/2010/main" Requires="p14">
+            <p:contentPart p14:bwMode="auto" r:id="rId182">
+              <p14:nvContentPartPr>
+                <p14:cNvPr id="154" name="Ink 153">
+                  <a:extLst>
+                    <a:ext uri="{FF2B5EF4-FFF2-40B4-BE49-F238E27FC236}">
+                      <a16:creationId xmlns:a16="http://schemas.microsoft.com/office/drawing/2014/main" id="{86CE4EE0-F24D-ED8F-1212-81F8C139EFF5}"/>
+                    </a:ext>
+                  </a:extLst>
+                </p14:cNvPr>
+                <p14:cNvContentPartPr/>
+                <p14:nvPr/>
+              </p14:nvContentPartPr>
+              <p14:xfrm>
+                <a:off x="4020030" y="2925822"/>
+                <a:ext cx="160920" cy="184320"/>
+              </p14:xfrm>
+            </p:contentPart>
+          </mc:Choice>
+          <mc:Fallback>
+            <p:pic>
+              <p:nvPicPr>
+                <p:cNvPr id="154" name="Ink 153">
+                  <a:extLst>
+                    <a:ext uri="{FF2B5EF4-FFF2-40B4-BE49-F238E27FC236}">
+                      <a16:creationId xmlns:a16="http://schemas.microsoft.com/office/drawing/2014/main" id="{86CE4EE0-F24D-ED8F-1212-81F8C139EFF5}"/>
+                    </a:ext>
+                  </a:extLst>
+                </p:cNvPr>
+                <p:cNvPicPr/>
+                <p:nvPr/>
+              </p:nvPicPr>
+              <p:blipFill>
+                <a:blip r:embed="rId183"/>
+                <a:stretch>
+                  <a:fillRect/>
+                </a:stretch>
+              </p:blipFill>
+              <p:spPr>
+                <a:xfrm>
+                  <a:off x="4011390" y="2916822"/>
+                  <a:ext cx="178560" cy="201960"/>
+                </a:xfrm>
+                <a:prstGeom prst="rect">
+                  <a:avLst/>
+                </a:prstGeom>
+              </p:spPr>
+            </p:pic>
+          </mc:Fallback>
+        </mc:AlternateContent>
+        <mc:AlternateContent xmlns:mc="http://schemas.openxmlformats.org/markup-compatibility/2006">
+          <mc:Choice xmlns:p14="http://schemas.microsoft.com/office/powerpoint/2010/main" Requires="p14">
+            <p:contentPart p14:bwMode="auto" r:id="rId184">
+              <p14:nvContentPartPr>
+                <p14:cNvPr id="155" name="Ink 154">
+                  <a:extLst>
+                    <a:ext uri="{FF2B5EF4-FFF2-40B4-BE49-F238E27FC236}">
+                      <a16:creationId xmlns:a16="http://schemas.microsoft.com/office/drawing/2014/main" id="{EC594048-D7E9-5E05-905F-8AAA8DBF1DC1}"/>
+                    </a:ext>
+                  </a:extLst>
+                </p14:cNvPr>
+                <p14:cNvContentPartPr/>
+                <p14:nvPr/>
+              </p14:nvContentPartPr>
+              <p14:xfrm>
+                <a:off x="1960830" y="1629462"/>
+                <a:ext cx="2199600" cy="1896120"/>
+              </p14:xfrm>
+            </p:contentPart>
+          </mc:Choice>
+          <mc:Fallback>
+            <p:pic>
+              <p:nvPicPr>
+                <p:cNvPr id="155" name="Ink 154">
+                  <a:extLst>
+                    <a:ext uri="{FF2B5EF4-FFF2-40B4-BE49-F238E27FC236}">
+                      <a16:creationId xmlns:a16="http://schemas.microsoft.com/office/drawing/2014/main" id="{EC594048-D7E9-5E05-905F-8AAA8DBF1DC1}"/>
+                    </a:ext>
+                  </a:extLst>
+                </p:cNvPr>
+                <p:cNvPicPr/>
+                <p:nvPr/>
+              </p:nvPicPr>
+              <p:blipFill>
+                <a:blip r:embed="rId185"/>
+                <a:stretch>
+                  <a:fillRect/>
+                </a:stretch>
+              </p:blipFill>
+              <p:spPr>
+                <a:xfrm>
+                  <a:off x="1951830" y="1620462"/>
+                  <a:ext cx="2217240" cy="1913760"/>
+                </a:xfrm>
+                <a:prstGeom prst="rect">
+                  <a:avLst/>
+                </a:prstGeom>
+              </p:spPr>
+            </p:pic>
+          </mc:Fallback>
+        </mc:AlternateContent>
+        <mc:AlternateContent xmlns:mc="http://schemas.openxmlformats.org/markup-compatibility/2006">
+          <mc:Choice xmlns:p14="http://schemas.microsoft.com/office/powerpoint/2010/main" Requires="p14">
+            <p:contentPart p14:bwMode="auto" r:id="rId186">
+              <p14:nvContentPartPr>
+                <p14:cNvPr id="157" name="Ink 156">
+                  <a:extLst>
+                    <a:ext uri="{FF2B5EF4-FFF2-40B4-BE49-F238E27FC236}">
+                      <a16:creationId xmlns:a16="http://schemas.microsoft.com/office/drawing/2014/main" id="{41535F26-B0CF-4798-25A2-F3C860D06EFE}"/>
+                    </a:ext>
+                  </a:extLst>
+                </p14:cNvPr>
+                <p14:cNvContentPartPr/>
+                <p14:nvPr/>
+              </p14:nvContentPartPr>
+              <p14:xfrm>
+                <a:off x="3950910" y="1389342"/>
+                <a:ext cx="287640" cy="101520"/>
+              </p14:xfrm>
+            </p:contentPart>
+          </mc:Choice>
+          <mc:Fallback>
+            <p:pic>
+              <p:nvPicPr>
+                <p:cNvPr id="157" name="Ink 156">
+                  <a:extLst>
+                    <a:ext uri="{FF2B5EF4-FFF2-40B4-BE49-F238E27FC236}">
+                      <a16:creationId xmlns:a16="http://schemas.microsoft.com/office/drawing/2014/main" id="{41535F26-B0CF-4798-25A2-F3C860D06EFE}"/>
+                    </a:ext>
+                  </a:extLst>
+                </p:cNvPr>
+                <p:cNvPicPr/>
+                <p:nvPr/>
+              </p:nvPicPr>
+              <p:blipFill>
+                <a:blip r:embed="rId187"/>
+                <a:stretch>
+                  <a:fillRect/>
+                </a:stretch>
+              </p:blipFill>
+              <p:spPr>
+                <a:xfrm>
+                  <a:off x="3942270" y="1380342"/>
+                  <a:ext cx="305280" cy="119160"/>
+                </a:xfrm>
+                <a:prstGeom prst="rect">
+                  <a:avLst/>
+                </a:prstGeom>
+              </p:spPr>
+            </p:pic>
+          </mc:Fallback>
+        </mc:AlternateContent>
+        <mc:AlternateContent xmlns:mc="http://schemas.openxmlformats.org/markup-compatibility/2006">
+          <mc:Choice xmlns:p14="http://schemas.microsoft.com/office/powerpoint/2010/main" Requires="p14">
+            <p:contentPart p14:bwMode="auto" r:id="rId188">
+              <p14:nvContentPartPr>
+                <p14:cNvPr id="158" name="Ink 157">
+                  <a:extLst>
+                    <a:ext uri="{FF2B5EF4-FFF2-40B4-BE49-F238E27FC236}">
+                      <a16:creationId xmlns:a16="http://schemas.microsoft.com/office/drawing/2014/main" id="{51BE543C-C448-9F03-CD3D-D110C97BB92B}"/>
+                    </a:ext>
+                  </a:extLst>
+                </p14:cNvPr>
+                <p14:cNvContentPartPr/>
+                <p14:nvPr/>
+              </p14:nvContentPartPr>
+              <p14:xfrm>
+                <a:off x="3944070" y="1508142"/>
+                <a:ext cx="310680" cy="77040"/>
+              </p14:xfrm>
+            </p:contentPart>
+          </mc:Choice>
+          <mc:Fallback>
+            <p:pic>
+              <p:nvPicPr>
+                <p:cNvPr id="158" name="Ink 157">
+                  <a:extLst>
+                    <a:ext uri="{FF2B5EF4-FFF2-40B4-BE49-F238E27FC236}">
+                      <a16:creationId xmlns:a16="http://schemas.microsoft.com/office/drawing/2014/main" id="{51BE543C-C448-9F03-CD3D-D110C97BB92B}"/>
+                    </a:ext>
+                  </a:extLst>
+                </p:cNvPr>
+                <p:cNvPicPr/>
+                <p:nvPr/>
+              </p:nvPicPr>
+              <p:blipFill>
+                <a:blip r:embed="rId189"/>
+                <a:stretch>
+                  <a:fillRect/>
+                </a:stretch>
+              </p:blipFill>
+              <p:spPr>
+                <a:xfrm>
+                  <a:off x="3935070" y="1499142"/>
+                  <a:ext cx="328320" cy="94680"/>
+                </a:xfrm>
+                <a:prstGeom prst="rect">
+                  <a:avLst/>
+                </a:prstGeom>
+              </p:spPr>
+            </p:pic>
+          </mc:Fallback>
+        </mc:AlternateContent>
+        <mc:AlternateContent xmlns:mc="http://schemas.openxmlformats.org/markup-compatibility/2006">
+          <mc:Choice xmlns:p14="http://schemas.microsoft.com/office/powerpoint/2010/main" Requires="p14">
+            <p:contentPart p14:bwMode="auto" r:id="rId190">
+              <p14:nvContentPartPr>
+                <p14:cNvPr id="160" name="Ink 159">
+                  <a:extLst>
+                    <a:ext uri="{FF2B5EF4-FFF2-40B4-BE49-F238E27FC236}">
+                      <a16:creationId xmlns:a16="http://schemas.microsoft.com/office/drawing/2014/main" id="{EE0B6C15-C438-B0B2-A2DD-4946F4379AD0}"/>
+                    </a:ext>
+                  </a:extLst>
+                </p14:cNvPr>
+                <p14:cNvContentPartPr/>
+                <p14:nvPr/>
+              </p14:nvContentPartPr>
+              <p14:xfrm>
+                <a:off x="4098870" y="1054542"/>
+                <a:ext cx="1739880" cy="2157840"/>
+              </p14:xfrm>
+            </p:contentPart>
+          </mc:Choice>
+          <mc:Fallback>
+            <p:pic>
+              <p:nvPicPr>
+                <p:cNvPr id="160" name="Ink 159">
+                  <a:extLst>
+                    <a:ext uri="{FF2B5EF4-FFF2-40B4-BE49-F238E27FC236}">
+                      <a16:creationId xmlns:a16="http://schemas.microsoft.com/office/drawing/2014/main" id="{EE0B6C15-C438-B0B2-A2DD-4946F4379AD0}"/>
+                    </a:ext>
+                  </a:extLst>
+                </p:cNvPr>
+                <p:cNvPicPr/>
+                <p:nvPr/>
+              </p:nvPicPr>
+              <p:blipFill>
+                <a:blip r:embed="rId191"/>
+                <a:stretch>
+                  <a:fillRect/>
+                </a:stretch>
+              </p:blipFill>
+              <p:spPr>
+                <a:xfrm>
+                  <a:off x="4090230" y="1045902"/>
+                  <a:ext cx="1757520" cy="2175480"/>
+                </a:xfrm>
+                <a:prstGeom prst="rect">
+                  <a:avLst/>
+                </a:prstGeom>
+              </p:spPr>
+            </p:pic>
+          </mc:Fallback>
+        </mc:AlternateContent>
+        <mc:AlternateContent xmlns:mc="http://schemas.openxmlformats.org/markup-compatibility/2006">
+          <mc:Choice xmlns:p14="http://schemas.microsoft.com/office/powerpoint/2010/main" Requires="p14">
+            <p:contentPart p14:bwMode="auto" r:id="rId192">
+              <p14:nvContentPartPr>
+                <p14:cNvPr id="161" name="Ink 160">
+                  <a:extLst>
+                    <a:ext uri="{FF2B5EF4-FFF2-40B4-BE49-F238E27FC236}">
+                      <a16:creationId xmlns:a16="http://schemas.microsoft.com/office/drawing/2014/main" id="{21DAAF6A-3AFC-8C3D-77AB-970A2D5D39BE}"/>
+                    </a:ext>
+                  </a:extLst>
+                </p14:cNvPr>
+                <p14:cNvContentPartPr/>
+                <p14:nvPr/>
+              </p14:nvContentPartPr>
+              <p14:xfrm>
+                <a:off x="5891310" y="2926182"/>
+                <a:ext cx="928080" cy="649440"/>
+              </p14:xfrm>
+            </p:contentPart>
+          </mc:Choice>
+          <mc:Fallback>
+            <p:pic>
+              <p:nvPicPr>
+                <p:cNvPr id="161" name="Ink 160">
+                  <a:extLst>
+                    <a:ext uri="{FF2B5EF4-FFF2-40B4-BE49-F238E27FC236}">
+                      <a16:creationId xmlns:a16="http://schemas.microsoft.com/office/drawing/2014/main" id="{21DAAF6A-3AFC-8C3D-77AB-970A2D5D39BE}"/>
+                    </a:ext>
+                  </a:extLst>
+                </p:cNvPr>
+                <p:cNvPicPr/>
+                <p:nvPr/>
+              </p:nvPicPr>
+              <p:blipFill>
+                <a:blip r:embed="rId193"/>
+                <a:stretch>
+                  <a:fillRect/>
+                </a:stretch>
+              </p:blipFill>
+              <p:spPr>
+                <a:xfrm>
+                  <a:off x="5882670" y="2917182"/>
+                  <a:ext cx="945720" cy="667080"/>
+                </a:xfrm>
+                <a:prstGeom prst="rect">
+                  <a:avLst/>
+                </a:prstGeom>
+              </p:spPr>
+            </p:pic>
+          </mc:Fallback>
+        </mc:AlternateContent>
+      </p:grpSp>
+      <mc:AlternateContent xmlns:mc="http://schemas.openxmlformats.org/markup-compatibility/2006">
+        <mc:Choice xmlns:p14="http://schemas.microsoft.com/office/powerpoint/2010/main" Requires="p14">
+          <p:contentPart p14:bwMode="auto" r:id="rId194">
+            <p14:nvContentPartPr>
+              <p14:cNvPr id="163" name="Ink 162">
+                <a:extLst>
+                  <a:ext uri="{FF2B5EF4-FFF2-40B4-BE49-F238E27FC236}">
+                    <a16:creationId xmlns:a16="http://schemas.microsoft.com/office/drawing/2014/main" id="{CEB19B84-DFEB-5CD9-6089-9C7362CBFE95}"/>
+                  </a:ext>
+                </a:extLst>
+              </p14:cNvPr>
+              <p14:cNvContentPartPr/>
+              <p14:nvPr/>
+            </p14:nvContentPartPr>
+            <p14:xfrm>
+              <a:off x="6566670" y="3285822"/>
+              <a:ext cx="662400" cy="5400"/>
+            </p14:xfrm>
+          </p:contentPart>
+        </mc:Choice>
+        <mc:Fallback>
+          <p:pic>
+            <p:nvPicPr>
+              <p:cNvPr id="163" name="Ink 162">
+                <a:extLst>
+                  <a:ext uri="{FF2B5EF4-FFF2-40B4-BE49-F238E27FC236}">
+                    <a16:creationId xmlns:a16="http://schemas.microsoft.com/office/drawing/2014/main" id="{CEB19B84-DFEB-5CD9-6089-9C7362CBFE95}"/>
+                  </a:ext>
+                </a:extLst>
+              </p:cNvPr>
+              <p:cNvPicPr/>
+              <p:nvPr/>
+            </p:nvPicPr>
+            <p:blipFill>
+              <a:blip r:embed="rId195"/>
+              <a:stretch>
+                <a:fillRect/>
+              </a:stretch>
+            </p:blipFill>
+            <p:spPr>
+              <a:xfrm>
+                <a:off x="6558030" y="3276822"/>
+                <a:ext cx="680040" cy="23040"/>
+              </a:xfrm>
+              <a:prstGeom prst="rect">
+                <a:avLst/>
+              </a:prstGeom>
+            </p:spPr>
+          </p:pic>
+        </mc:Fallback>
+      </mc:AlternateContent>
     </p:spTree>
     <p:extLst>
       <p:ext uri="{BB962C8B-B14F-4D97-AF65-F5344CB8AC3E}">

</xml_diff>